<commit_message>
Commit final NB changes
</commit_message>
<xml_diff>
--- a/presentation docs/Copino_UBP_Presentation_Final.pptx
+++ b/presentation docs/Copino_UBP_Presentation_Final.pptx
@@ -237,7 +237,7 @@
           <a:p>
             <a:fld id="{8F0C7A2B-4258-4842-ADBD-6F50B0998435}" type="datetimeFigureOut">
               <a:rPr lang="en-PH" smtClean="0"/>
-              <a:t>15/03/2026</a:t>
+              <a:t>16/03/2026</a:t>
             </a:fld>
             <a:endParaRPr lang="en-PH"/>
           </a:p>
@@ -549,347 +549,6 @@
           <a:bodyPr/>
           <a:lstStyle/>
           <a:p>
-            <a:r>
-              <a:rPr lang="en-US" sz="1200" b="1" i="0" kern="1200" dirty="0">
-                <a:solidFill>
-                  <a:schemeClr val="tx1"/>
-                </a:solidFill>
-                <a:effectLst/>
-                <a:latin typeface="+mn-lt"/>
-                <a:ea typeface="+mn-ea"/>
-                <a:cs typeface="+mn-cs"/>
-              </a:rPr>
-              <a:t>Acquisition Cost (₱5,000 – ₱15,000 per client)</a:t>
-            </a:r>
-            <a:endParaRPr lang="en-US" sz="1200" b="0" i="0" kern="1200" dirty="0">
-              <a:solidFill>
-                <a:schemeClr val="tx1"/>
-              </a:solidFill>
-              <a:effectLst/>
-              <a:latin typeface="+mn-lt"/>
-              <a:ea typeface="+mn-ea"/>
-              <a:cs typeface="+mn-cs"/>
-            </a:endParaRPr>
-          </a:p>
-          <a:p>
-            <a:r>
-              <a:rPr lang="en-US" sz="1200" b="0" i="0" kern="1200" dirty="0">
-                <a:solidFill>
-                  <a:schemeClr val="tx1"/>
-                </a:solidFill>
-                <a:effectLst/>
-                <a:latin typeface="+mn-lt"/>
-                <a:ea typeface="+mn-ea"/>
-                <a:cs typeface="+mn-cs"/>
-              </a:rPr>
-              <a:t>Bain &amp; Company — </a:t>
-            </a:r>
-            <a:r>
-              <a:rPr lang="en-US" sz="1200" b="0" i="1" kern="1200" dirty="0">
-                <a:solidFill>
-                  <a:schemeClr val="tx1"/>
-                </a:solidFill>
-                <a:effectLst/>
-                <a:latin typeface="+mn-lt"/>
-                <a:ea typeface="+mn-ea"/>
-                <a:cs typeface="+mn-cs"/>
-              </a:rPr>
-              <a:t>The Value of Customer Loyalty</a:t>
-            </a:r>
-            <a:r>
-              <a:rPr lang="en-US" sz="1200" b="0" i="0" kern="1200" dirty="0">
-                <a:solidFill>
-                  <a:schemeClr val="tx1"/>
-                </a:solidFill>
-                <a:effectLst/>
-                <a:latin typeface="+mn-lt"/>
-                <a:ea typeface="+mn-ea"/>
-                <a:cs typeface="+mn-cs"/>
-              </a:rPr>
-              <a:t> (acquiring a new customer costs 5–25x more than retaining one)</a:t>
-            </a:r>
-          </a:p>
-          <a:p>
-            <a:r>
-              <a:rPr lang="en-US" sz="1200" b="0" i="0" kern="1200" dirty="0">
-                <a:solidFill>
-                  <a:schemeClr val="tx1"/>
-                </a:solidFill>
-                <a:effectLst/>
-                <a:latin typeface="+mn-lt"/>
-                <a:ea typeface="+mn-ea"/>
-                <a:cs typeface="+mn-cs"/>
-              </a:rPr>
-              <a:t>General banking industry benchmark</a:t>
-            </a:r>
-          </a:p>
-          <a:p>
-            <a:r>
-              <a:rPr lang="en-PH" sz="1200" b="0" i="0" kern="1200" dirty="0">
-                <a:solidFill>
-                  <a:schemeClr val="tx1"/>
-                </a:solidFill>
-                <a:effectLst/>
-                <a:latin typeface="+mn-lt"/>
-                <a:ea typeface="+mn-ea"/>
-                <a:cs typeface="+mn-cs"/>
-                <a:hlinkClick r:id="rId3"/>
-              </a:rPr>
-              <a:t>Source: </a:t>
-            </a:r>
-            <a:r>
-              <a:rPr lang="en-PH" sz="1200" b="0" i="0" kern="1200" dirty="0">
-                <a:solidFill>
-                  <a:schemeClr val="tx1"/>
-                </a:solidFill>
-                <a:effectLst/>
-                <a:latin typeface="+mn-lt"/>
-                <a:ea typeface="+mn-ea"/>
-                <a:cs typeface="+mn-cs"/>
-              </a:rPr>
-              <a:t>https://hbr.org/1990/09/zero-defections-quality-comes-to-services</a:t>
-            </a:r>
-          </a:p>
-          <a:p>
-            <a:endParaRPr lang="en-US" sz="1200" b="0" i="0" kern="1200" dirty="0">
-              <a:solidFill>
-                <a:schemeClr val="tx1"/>
-              </a:solidFill>
-              <a:effectLst/>
-              <a:latin typeface="+mn-lt"/>
-              <a:ea typeface="+mn-ea"/>
-              <a:cs typeface="+mn-cs"/>
-            </a:endParaRPr>
-          </a:p>
-          <a:p>
-            <a:r>
-              <a:rPr lang="en-PH" sz="1200" b="1" i="0" kern="1200" dirty="0">
-                <a:solidFill>
-                  <a:schemeClr val="tx1"/>
-                </a:solidFill>
-                <a:effectLst/>
-                <a:latin typeface="+mn-lt"/>
-                <a:ea typeface="+mn-ea"/>
-                <a:cs typeface="+mn-cs"/>
-              </a:rPr>
-              <a:t>Customer Lifetime Value </a:t>
-            </a:r>
-            <a:r>
-              <a:rPr lang="en-US" sz="1200" b="1" i="0" kern="1200" dirty="0">
-                <a:solidFill>
-                  <a:schemeClr val="tx1"/>
-                </a:solidFill>
-                <a:effectLst/>
-                <a:latin typeface="+mn-lt"/>
-                <a:ea typeface="+mn-ea"/>
-                <a:cs typeface="+mn-cs"/>
-              </a:rPr>
-              <a:t>(₱30,000 – ₱60,000 CLV, ~₱9,000/yr net)</a:t>
-            </a:r>
-            <a:endParaRPr lang="en-US" sz="1200" b="0" i="0" kern="1200" dirty="0">
-              <a:solidFill>
-                <a:schemeClr val="tx1"/>
-              </a:solidFill>
-              <a:effectLst/>
-              <a:latin typeface="+mn-lt"/>
-              <a:ea typeface="+mn-ea"/>
-              <a:cs typeface="+mn-cs"/>
-            </a:endParaRPr>
-          </a:p>
-          <a:p>
-            <a:r>
-              <a:rPr lang="en-US" sz="1200" b="0" i="0" kern="1200" dirty="0">
-                <a:solidFill>
-                  <a:schemeClr val="tx1"/>
-                </a:solidFill>
-                <a:effectLst/>
-                <a:latin typeface="+mn-lt"/>
-                <a:ea typeface="+mn-ea"/>
-                <a:cs typeface="+mn-cs"/>
-              </a:rPr>
-              <a:t>Source: https://www.bsp.gov.ph/Media_And_Research/FSR/FSR2024.pdf</a:t>
-            </a:r>
-          </a:p>
-          <a:p>
-            <a:endParaRPr lang="en-US" sz="1200" b="0" i="0" kern="1200" dirty="0">
-              <a:solidFill>
-                <a:schemeClr val="tx1"/>
-              </a:solidFill>
-              <a:effectLst/>
-              <a:latin typeface="+mn-lt"/>
-              <a:ea typeface="+mn-ea"/>
-              <a:cs typeface="+mn-cs"/>
-            </a:endParaRPr>
-          </a:p>
-          <a:p>
-            <a:r>
-              <a:rPr lang="en-US" b="1" dirty="0"/>
-              <a:t>Net annual revenue per cardholder (</a:t>
-            </a:r>
-            <a:r>
-              <a:rPr lang="en-PH" dirty="0"/>
-              <a:t>~₱9,000 / yr)</a:t>
-            </a:r>
-            <a:endParaRPr lang="en-US" b="1" dirty="0"/>
-          </a:p>
-          <a:p>
-            <a:pPr marL="0" marR="0" lvl="0" indent="0" algn="l" defTabSz="914400" rtl="0" eaLnBrk="1" fontAlgn="auto" latinLnBrk="0" hangingPunct="1">
-              <a:lnSpc>
-                <a:spcPct val="100000"/>
-              </a:lnSpc>
-              <a:spcBef>
-                <a:spcPts val="0"/>
-              </a:spcBef>
-              <a:spcAft>
-                <a:spcPts val="0"/>
-              </a:spcAft>
-              <a:buClrTx/>
-              <a:buSzTx/>
-              <a:buFontTx/>
-              <a:buNone/>
-              <a:tabLst/>
-              <a:defRPr/>
-            </a:pPr>
-            <a:r>
-              <a:rPr lang="en-US" sz="1200" b="0" i="0" kern="1200" dirty="0">
-                <a:solidFill>
-                  <a:schemeClr val="tx1"/>
-                </a:solidFill>
-                <a:effectLst/>
-                <a:latin typeface="+mn-lt"/>
-                <a:ea typeface="+mn-ea"/>
-                <a:cs typeface="+mn-cs"/>
-              </a:rPr>
-              <a:t>Source: https://www.bsp.gov.ph/Media_And_Research/Consumer%20Finance%20Survey/CFS_2021.pdf</a:t>
-            </a:r>
-          </a:p>
-          <a:p>
-            <a:endParaRPr lang="en-US" sz="1200" b="0" i="0" kern="1200" dirty="0">
-              <a:solidFill>
-                <a:schemeClr val="tx1"/>
-              </a:solidFill>
-              <a:effectLst/>
-              <a:latin typeface="+mn-lt"/>
-              <a:ea typeface="+mn-ea"/>
-              <a:cs typeface="+mn-cs"/>
-            </a:endParaRPr>
-          </a:p>
-          <a:p>
-            <a:r>
-              <a:rPr lang="en-US" sz="1200" b="1" i="0" kern="1200" dirty="0">
-                <a:solidFill>
-                  <a:schemeClr val="tx1"/>
-                </a:solidFill>
-                <a:effectLst/>
-                <a:latin typeface="+mn-lt"/>
-                <a:ea typeface="+mn-ea"/>
-                <a:cs typeface="+mn-cs"/>
-              </a:rPr>
-              <a:t>Retention Program Success Rate (40%)</a:t>
-            </a:r>
-            <a:endParaRPr lang="en-US" sz="1200" b="0" i="0" kern="1200" dirty="0">
-              <a:solidFill>
-                <a:schemeClr val="tx1"/>
-              </a:solidFill>
-              <a:effectLst/>
-              <a:latin typeface="+mn-lt"/>
-              <a:ea typeface="+mn-ea"/>
-              <a:cs typeface="+mn-cs"/>
-            </a:endParaRPr>
-          </a:p>
-          <a:p>
-            <a:r>
-              <a:rPr lang="en-US" sz="1200" b="0" i="0" kern="1200" dirty="0">
-                <a:solidFill>
-                  <a:schemeClr val="tx1"/>
-                </a:solidFill>
-                <a:effectLst/>
-                <a:latin typeface="+mn-lt"/>
-                <a:ea typeface="+mn-ea"/>
-                <a:cs typeface="+mn-cs"/>
-              </a:rPr>
-              <a:t>Bain &amp; Company — proactive retention interventions in financial services typically convert 30–50% of at-risk customers</a:t>
-            </a:r>
-          </a:p>
-          <a:p>
-            <a:r>
-              <a:rPr lang="en-US" sz="1200" b="1" i="0" kern="1200" dirty="0">
-                <a:solidFill>
-                  <a:schemeClr val="tx1"/>
-                </a:solidFill>
-                <a:effectLst/>
-                <a:latin typeface="+mn-lt"/>
-                <a:ea typeface="+mn-ea"/>
-                <a:cs typeface="+mn-cs"/>
-              </a:rPr>
-              <a:t>The ₱6,950,000 net EV figure</a:t>
-            </a:r>
-            <a:r>
-              <a:rPr lang="en-US" sz="1200" b="0" i="0" kern="1200" dirty="0">
-                <a:solidFill>
-                  <a:schemeClr val="tx1"/>
-                </a:solidFill>
-                <a:effectLst/>
-                <a:latin typeface="+mn-lt"/>
-                <a:ea typeface="+mn-ea"/>
-                <a:cs typeface="+mn-cs"/>
-              </a:rPr>
-              <a:t> was derived from the formula we built:</a:t>
-            </a:r>
-          </a:p>
-          <a:p>
-            <a:r>
-              <a:rPr lang="en-US" sz="1200" b="0" i="0" kern="1200" dirty="0">
-                <a:solidFill>
-                  <a:schemeClr val="tx1"/>
-                </a:solidFill>
-                <a:effectLst/>
-                <a:latin typeface="+mn-lt"/>
-                <a:ea typeface="+mn-ea"/>
-                <a:cs typeface="+mn-cs"/>
-              </a:rPr>
-              <a:t>EV = (Predicted </a:t>
-            </a:r>
-            <a:r>
-              <a:rPr lang="en-US" sz="1200" b="0" i="0" kern="1200" dirty="0" err="1">
-                <a:solidFill>
-                  <a:schemeClr val="tx1"/>
-                </a:solidFill>
-                <a:effectLst/>
-                <a:latin typeface="+mn-lt"/>
-                <a:ea typeface="+mn-ea"/>
-                <a:cs typeface="+mn-cs"/>
-              </a:rPr>
-              <a:t>Attriters</a:t>
-            </a:r>
-            <a:r>
-              <a:rPr lang="en-US" sz="1200" b="0" i="0" kern="1200" dirty="0">
-                <a:solidFill>
-                  <a:schemeClr val="tx1"/>
-                </a:solidFill>
-                <a:effectLst/>
-                <a:latin typeface="+mn-lt"/>
-                <a:ea typeface="+mn-ea"/>
-                <a:cs typeface="+mn-cs"/>
-              </a:rPr>
-              <a:t> × Success Rate × CLV saved) − (Intervention Cost × Predicted </a:t>
-            </a:r>
-          </a:p>
-          <a:p>
-            <a:r>
-              <a:rPr lang="en-US" sz="1200" b="0" i="0" kern="1200" dirty="0">
-                <a:solidFill>
-                  <a:schemeClr val="tx1"/>
-                </a:solidFill>
-                <a:effectLst/>
-                <a:latin typeface="+mn-lt"/>
-                <a:ea typeface="+mn-ea"/>
-                <a:cs typeface="+mn-cs"/>
-              </a:rPr>
-              <a:t>Source: https://www.bain.com/insights/customer-loyalty-in-retail-banking-2013/</a:t>
-            </a:r>
-          </a:p>
-          <a:p>
             <a:endParaRPr lang="en-PH" dirty="0"/>
           </a:p>
         </p:txBody>
@@ -974,28 +633,7 @@
           <a:bodyPr/>
           <a:lstStyle/>
           <a:p>
-            <a:r>
-              <a:rPr lang="en-PH" dirty="0"/>
-              <a:t>Chi2 is raw statistic translated to p, depends on degrees of freedom and sample size </a:t>
-            </a:r>
-          </a:p>
-          <a:p>
             <a:endParaRPr lang="en-PH" dirty="0"/>
-          </a:p>
-          <a:p>
-            <a:r>
-              <a:rPr lang="en-PH" dirty="0"/>
-              <a:t>P = 0.432 -&gt; 43.2 % that the effect of this feature is random</a:t>
-            </a:r>
-          </a:p>
-          <a:p>
-            <a:endParaRPr lang="en-PH" dirty="0"/>
-          </a:p>
-          <a:p>
-            <a:r>
-              <a:rPr lang="en-PH" dirty="0"/>
-              <a:t>V = strength of association (&gt;0.20 is preferred)</a:t>
-            </a:r>
           </a:p>
         </p:txBody>
       </p:sp>
@@ -1016,7 +654,7 @@
           <a:p>
             <a:fld id="{BA95E93F-2514-4B81-921C-6961CBA23D3B}" type="slidenum">
               <a:rPr lang="en-PH" smtClean="0"/>
-              <a:t>18</a:t>
+              <a:t>16</a:t>
             </a:fld>
             <a:endParaRPr lang="en-PH"/>
           </a:p>
@@ -1025,7 +663,7 @@
     </p:spTree>
     <p:extLst>
       <p:ext uri="{BB962C8B-B14F-4D97-AF65-F5344CB8AC3E}">
-        <p14:creationId xmlns:p14="http://schemas.microsoft.com/office/powerpoint/2010/main" val="963100552"/>
+        <p14:creationId xmlns:p14="http://schemas.microsoft.com/office/powerpoint/2010/main" val="3107776484"/>
       </p:ext>
     </p:extLst>
   </p:cSld>
@@ -1079,456 +717,6 @@
           <a:bodyPr/>
           <a:lstStyle/>
           <a:p>
-            <a:r>
-              <a:rPr lang="en-PH" dirty="0"/>
-              <a:t>Feature selection guidelines:</a:t>
-            </a:r>
-          </a:p>
-          <a:p>
-            <a:endParaRPr lang="en-PH" dirty="0"/>
-          </a:p>
-          <a:p>
-            <a:pPr marL="228600" indent="-228600">
-              <a:buAutoNum type="arabicPeriod"/>
-            </a:pPr>
-            <a:r>
-              <a:rPr lang="en-PH" dirty="0"/>
-              <a:t>Welch’s T-test (numeric) / Chi-square (categorical) vs </a:t>
-            </a:r>
-            <a:r>
-              <a:rPr lang="en-PH" dirty="0" err="1"/>
-              <a:t>AttritionFlag</a:t>
-            </a:r>
-            <a:endParaRPr lang="en-PH" dirty="0"/>
-          </a:p>
-          <a:p>
-            <a:pPr marL="228600" marR="0" lvl="0" indent="-228600" algn="l" defTabSz="914400" rtl="0" eaLnBrk="1" fontAlgn="auto" latinLnBrk="0" hangingPunct="1">
-              <a:lnSpc>
-                <a:spcPct val="100000"/>
-              </a:lnSpc>
-              <a:spcBef>
-                <a:spcPts val="0"/>
-              </a:spcBef>
-              <a:spcAft>
-                <a:spcPts val="0"/>
-              </a:spcAft>
-              <a:buClrTx/>
-              <a:buSzTx/>
-              <a:buFont typeface="Arial" panose="020B0604020202020204" pitchFamily="34" charset="0"/>
-              <a:buChar char="•"/>
-              <a:tabLst/>
-              <a:defRPr/>
-            </a:pPr>
-            <a:r>
-              <a:rPr lang="en-PH" dirty="0"/>
-              <a:t>Only </a:t>
-            </a:r>
-            <a:r>
-              <a:rPr lang="en-US" sz="1200" b="1" dirty="0" err="1">
-                <a:solidFill>
-                  <a:srgbClr val="4B4B4B"/>
-                </a:solidFill>
-                <a:latin typeface="Arial" panose="020B0604020202020204" pitchFamily="34" charset="0"/>
-              </a:rPr>
-              <a:t>Avg_Spend_per_Tenure_Year</a:t>
-            </a:r>
-            <a:r>
-              <a:rPr lang="en-PH" sz="1200" b="1" dirty="0">
-                <a:solidFill>
-                  <a:srgbClr val="4B4B4B"/>
-                </a:solidFill>
-                <a:latin typeface="Arial" panose="020B0604020202020204" pitchFamily="34" charset="0"/>
-              </a:rPr>
-              <a:t> (</a:t>
-            </a:r>
-            <a:r>
-              <a:rPr lang="en-PH" sz="1200" b="0" i="0" kern="1200" dirty="0">
-                <a:solidFill>
-                  <a:schemeClr val="tx1"/>
-                </a:solidFill>
-                <a:effectLst/>
-                <a:latin typeface="+mn-lt"/>
-                <a:ea typeface="+mn-ea"/>
-                <a:cs typeface="+mn-cs"/>
-              </a:rPr>
-              <a:t>0.040317) </a:t>
-            </a:r>
-            <a:r>
-              <a:rPr lang="en-PH" sz="1200" b="1" dirty="0">
-                <a:solidFill>
-                  <a:srgbClr val="4B4B4B"/>
-                </a:solidFill>
-                <a:latin typeface="Arial" panose="020B0604020202020204" pitchFamily="34" charset="0"/>
-              </a:rPr>
-              <a:t>and </a:t>
-            </a:r>
-            <a:r>
-              <a:rPr lang="en-PH" dirty="0"/>
-              <a:t> </a:t>
-            </a:r>
-            <a:r>
-              <a:rPr lang="en-US" dirty="0" err="1"/>
-              <a:t>Avg_Txn_per_Tenure_Year</a:t>
-            </a:r>
-            <a:r>
-              <a:rPr lang="en-PH" dirty="0"/>
-              <a:t> </a:t>
-            </a:r>
-            <a:r>
-              <a:rPr lang="en-PH" sz="1200" b="1" dirty="0">
-                <a:solidFill>
-                  <a:srgbClr val="4B4B4B"/>
-                </a:solidFill>
-                <a:latin typeface="Arial" panose="020B0604020202020204" pitchFamily="34" charset="0"/>
-              </a:rPr>
-              <a:t>are significant (</a:t>
-            </a:r>
-            <a:r>
-              <a:rPr lang="en-PH" sz="1200" b="0" i="0" kern="1200" dirty="0">
-                <a:solidFill>
-                  <a:schemeClr val="tx1"/>
-                </a:solidFill>
-                <a:effectLst/>
-                <a:latin typeface="+mn-lt"/>
-                <a:ea typeface="+mn-ea"/>
-                <a:cs typeface="+mn-cs"/>
-              </a:rPr>
-              <a:t>0.024801)</a:t>
-            </a:r>
-            <a:endParaRPr lang="en-PH" sz="1200" b="1" dirty="0">
-              <a:solidFill>
-                <a:srgbClr val="4B4B4B"/>
-              </a:solidFill>
-              <a:latin typeface="Arial" panose="020B0604020202020204" pitchFamily="34" charset="0"/>
-            </a:endParaRPr>
-          </a:p>
-          <a:p>
-            <a:pPr marL="228600" marR="0" lvl="0" indent="-228600" algn="l" defTabSz="914400" rtl="0" eaLnBrk="1" fontAlgn="auto" latinLnBrk="0" hangingPunct="1">
-              <a:lnSpc>
-                <a:spcPct val="100000"/>
-              </a:lnSpc>
-              <a:spcBef>
-                <a:spcPts val="0"/>
-              </a:spcBef>
-              <a:spcAft>
-                <a:spcPts val="0"/>
-              </a:spcAft>
-              <a:buClrTx/>
-              <a:buSzTx/>
-              <a:buFont typeface="Arial" panose="020B0604020202020204" pitchFamily="34" charset="0"/>
-              <a:buChar char="•"/>
-              <a:tabLst/>
-              <a:defRPr/>
-            </a:pPr>
-            <a:endParaRPr lang="en-PH" sz="1200" b="1" dirty="0">
-              <a:solidFill>
-                <a:srgbClr val="4B4B4B"/>
-              </a:solidFill>
-              <a:latin typeface="Arial" panose="020B0604020202020204" pitchFamily="34" charset="0"/>
-            </a:endParaRPr>
-          </a:p>
-          <a:p>
-            <a:pPr marL="0" marR="0" lvl="0" indent="0" algn="l" defTabSz="914400" rtl="0" eaLnBrk="1" fontAlgn="auto" latinLnBrk="0" hangingPunct="1">
-              <a:lnSpc>
-                <a:spcPct val="100000"/>
-              </a:lnSpc>
-              <a:spcBef>
-                <a:spcPts val="0"/>
-              </a:spcBef>
-              <a:spcAft>
-                <a:spcPts val="0"/>
-              </a:spcAft>
-              <a:buClrTx/>
-              <a:buSzTx/>
-              <a:buFont typeface="Arial" panose="020B0604020202020204" pitchFamily="34" charset="0"/>
-              <a:buNone/>
-              <a:tabLst/>
-              <a:defRPr/>
-            </a:pPr>
-            <a:r>
-              <a:rPr lang="en-PH" sz="1200" b="1" dirty="0">
-                <a:solidFill>
-                  <a:srgbClr val="4B4B4B"/>
-                </a:solidFill>
-                <a:latin typeface="Arial" panose="020B0604020202020204" pitchFamily="34" charset="0"/>
-              </a:rPr>
-              <a:t>2. Cohen’s d (numerical) / Cramer’s V ( categorical)</a:t>
-            </a:r>
-          </a:p>
-          <a:p>
-            <a:pPr marL="228600" marR="0" lvl="0" indent="-228600" algn="l" defTabSz="914400" rtl="0" eaLnBrk="1" fontAlgn="auto" latinLnBrk="0" hangingPunct="1">
-              <a:lnSpc>
-                <a:spcPct val="100000"/>
-              </a:lnSpc>
-              <a:spcBef>
-                <a:spcPts val="0"/>
-              </a:spcBef>
-              <a:spcAft>
-                <a:spcPts val="0"/>
-              </a:spcAft>
-              <a:buClrTx/>
-              <a:buSzTx/>
-              <a:buFont typeface="Arial" panose="020B0604020202020204" pitchFamily="34" charset="0"/>
-              <a:buChar char="•"/>
-              <a:tabLst/>
-              <a:defRPr/>
-            </a:pPr>
-            <a:r>
-              <a:rPr lang="en-PH" dirty="0"/>
-              <a:t>Top 2: </a:t>
-            </a:r>
-            <a:r>
-              <a:rPr lang="en-US" sz="1200" b="1" dirty="0" err="1">
-                <a:solidFill>
-                  <a:srgbClr val="4B4B4B"/>
-                </a:solidFill>
-                <a:latin typeface="Arial" panose="020B0604020202020204" pitchFamily="34" charset="0"/>
-              </a:rPr>
-              <a:t>Avg_Spend_per_Tenure_Year</a:t>
-            </a:r>
-            <a:r>
-              <a:rPr lang="en-PH" sz="1200" b="1" dirty="0">
-                <a:solidFill>
-                  <a:srgbClr val="4B4B4B"/>
-                </a:solidFill>
-                <a:latin typeface="Arial" panose="020B0604020202020204" pitchFamily="34" charset="0"/>
-              </a:rPr>
-              <a:t> and </a:t>
-            </a:r>
-            <a:r>
-              <a:rPr lang="en-PH" dirty="0"/>
-              <a:t> </a:t>
-            </a:r>
-            <a:r>
-              <a:rPr lang="en-US" sz="1200" b="1" dirty="0" err="1">
-                <a:solidFill>
-                  <a:srgbClr val="4B4B4B"/>
-                </a:solidFill>
-                <a:latin typeface="Arial" panose="020B0604020202020204" pitchFamily="34" charset="0"/>
-              </a:rPr>
-              <a:t>Avg_Txn_per_Tenure_Year</a:t>
-            </a:r>
-            <a:endParaRPr lang="en-PH" sz="1200" b="1" dirty="0">
-              <a:solidFill>
-                <a:srgbClr val="4B4B4B"/>
-              </a:solidFill>
-              <a:latin typeface="Arial" panose="020B0604020202020204" pitchFamily="34" charset="0"/>
-            </a:endParaRPr>
-          </a:p>
-          <a:p>
-            <a:pPr marL="0" marR="0" lvl="0" indent="0" algn="l" defTabSz="914400" rtl="0" eaLnBrk="1" fontAlgn="auto" latinLnBrk="0" hangingPunct="1">
-              <a:lnSpc>
-                <a:spcPct val="100000"/>
-              </a:lnSpc>
-              <a:spcBef>
-                <a:spcPts val="0"/>
-              </a:spcBef>
-              <a:spcAft>
-                <a:spcPts val="0"/>
-              </a:spcAft>
-              <a:buClrTx/>
-              <a:buSzTx/>
-              <a:buFont typeface="Arial" panose="020B0604020202020204" pitchFamily="34" charset="0"/>
-              <a:buNone/>
-              <a:tabLst/>
-              <a:defRPr/>
-            </a:pPr>
-            <a:endParaRPr lang="en-PH" dirty="0"/>
-          </a:p>
-          <a:p>
-            <a:pPr marL="0" marR="0" lvl="0" indent="0" algn="l" defTabSz="914400" rtl="0" eaLnBrk="1" fontAlgn="auto" latinLnBrk="0" hangingPunct="1">
-              <a:lnSpc>
-                <a:spcPct val="100000"/>
-              </a:lnSpc>
-              <a:spcBef>
-                <a:spcPts val="0"/>
-              </a:spcBef>
-              <a:spcAft>
-                <a:spcPts val="0"/>
-              </a:spcAft>
-              <a:buClrTx/>
-              <a:buSzTx/>
-              <a:buFont typeface="Arial" panose="020B0604020202020204" pitchFamily="34" charset="0"/>
-              <a:buNone/>
-              <a:tabLst/>
-              <a:defRPr/>
-            </a:pPr>
-            <a:r>
-              <a:rPr lang="en-PH" dirty="0"/>
-              <a:t>3. VIF </a:t>
-            </a:r>
-          </a:p>
-          <a:p>
-            <a:pPr marL="171450" marR="0" lvl="0" indent="-171450" algn="l" defTabSz="914400" rtl="0" eaLnBrk="1" fontAlgn="auto" latinLnBrk="0" hangingPunct="1">
-              <a:lnSpc>
-                <a:spcPct val="100000"/>
-              </a:lnSpc>
-              <a:spcBef>
-                <a:spcPts val="0"/>
-              </a:spcBef>
-              <a:spcAft>
-                <a:spcPts val="0"/>
-              </a:spcAft>
-              <a:buClrTx/>
-              <a:buSzTx/>
-              <a:buFont typeface="Arial" panose="020B0604020202020204" pitchFamily="34" charset="0"/>
-              <a:buChar char="•"/>
-              <a:tabLst/>
-              <a:defRPr/>
-            </a:pPr>
-            <a:r>
-              <a:rPr lang="en-PH" dirty="0"/>
-              <a:t>However, VIF for the top 2 are linearly correlated (based on Pearson R) so I chose the lower p-value and higher </a:t>
-            </a:r>
-            <a:r>
-              <a:rPr lang="en-PH" dirty="0" err="1"/>
-              <a:t>cohen’s</a:t>
-            </a:r>
-            <a:r>
-              <a:rPr lang="en-PH" dirty="0"/>
-              <a:t> d</a:t>
-            </a:r>
-          </a:p>
-          <a:p>
-            <a:pPr marL="171450" marR="0" lvl="0" indent="-171450" algn="l" defTabSz="914400" rtl="0" eaLnBrk="1" fontAlgn="auto" latinLnBrk="0" hangingPunct="1">
-              <a:lnSpc>
-                <a:spcPct val="100000"/>
-              </a:lnSpc>
-              <a:spcBef>
-                <a:spcPts val="0"/>
-              </a:spcBef>
-              <a:spcAft>
-                <a:spcPts val="0"/>
-              </a:spcAft>
-              <a:buClrTx/>
-              <a:buSzTx/>
-              <a:buFont typeface="Arial" panose="020B0604020202020204" pitchFamily="34" charset="0"/>
-              <a:buChar char="•"/>
-              <a:tabLst/>
-              <a:defRPr/>
-            </a:pPr>
-            <a:r>
-              <a:rPr lang="en-PH" dirty="0"/>
-              <a:t>Retain </a:t>
-            </a:r>
-            <a:r>
-              <a:rPr lang="en-PH" dirty="0" err="1"/>
-              <a:t>Avg_Txn_per_Tenure_Year</a:t>
-            </a:r>
-            <a:r>
-              <a:rPr lang="en-PH" dirty="0"/>
-              <a:t> (p = </a:t>
-            </a:r>
-            <a:r>
-              <a:rPr lang="en-PH" sz="1200" b="0" i="0" kern="1200" dirty="0">
-                <a:solidFill>
-                  <a:schemeClr val="tx1"/>
-                </a:solidFill>
-                <a:effectLst/>
-                <a:latin typeface="+mn-lt"/>
-                <a:ea typeface="+mn-ea"/>
-                <a:cs typeface="+mn-cs"/>
-              </a:rPr>
-              <a:t>0.024801</a:t>
-            </a:r>
-            <a:r>
-              <a:rPr lang="en-PH" dirty="0"/>
-              <a:t> &lt; 0.05)</a:t>
-            </a:r>
-          </a:p>
-          <a:p>
-            <a:pPr marL="171450" marR="0" lvl="0" indent="-171450" algn="l" defTabSz="914400" rtl="0" eaLnBrk="1" fontAlgn="auto" latinLnBrk="0" hangingPunct="1">
-              <a:lnSpc>
-                <a:spcPct val="100000"/>
-              </a:lnSpc>
-              <a:spcBef>
-                <a:spcPts val="0"/>
-              </a:spcBef>
-              <a:spcAft>
-                <a:spcPts val="0"/>
-              </a:spcAft>
-              <a:buClrTx/>
-              <a:buSzTx/>
-              <a:buFont typeface="Arial" panose="020B0604020202020204" pitchFamily="34" charset="0"/>
-              <a:buChar char="•"/>
-              <a:tabLst/>
-              <a:defRPr/>
-            </a:pPr>
-            <a:r>
-              <a:rPr lang="en-US" sz="1200" b="0" i="0" kern="1200" dirty="0">
-                <a:solidFill>
-                  <a:schemeClr val="tx1"/>
-                </a:solidFill>
-                <a:effectLst/>
-                <a:latin typeface="+mn-lt"/>
-                <a:ea typeface="+mn-ea"/>
-                <a:cs typeface="+mn-cs"/>
-              </a:rPr>
-              <a:t>p = 0.024 → 2.4% chance the difference between churners and stayers on avg </a:t>
-            </a:r>
-            <a:r>
-              <a:rPr lang="en-US" sz="1200" b="0" i="0" kern="1200" dirty="0" err="1">
-                <a:solidFill>
-                  <a:schemeClr val="tx1"/>
-                </a:solidFill>
-                <a:effectLst/>
-                <a:latin typeface="+mn-lt"/>
-                <a:ea typeface="+mn-ea"/>
-                <a:cs typeface="+mn-cs"/>
-              </a:rPr>
-              <a:t>txn</a:t>
-            </a:r>
-            <a:r>
-              <a:rPr lang="en-US" sz="1200" b="0" i="0" kern="1200" dirty="0">
-                <a:solidFill>
-                  <a:schemeClr val="tx1"/>
-                </a:solidFill>
-                <a:effectLst/>
-                <a:latin typeface="+mn-lt"/>
-                <a:ea typeface="+mn-ea"/>
-                <a:cs typeface="+mn-cs"/>
-              </a:rPr>
-              <a:t> per tenure year is just random noise. Way below the 0.05 threshold.</a:t>
-            </a:r>
-          </a:p>
-          <a:p>
-            <a:pPr marL="171450" marR="0" lvl="0" indent="-171450" algn="l" defTabSz="914400" rtl="0" eaLnBrk="1" fontAlgn="auto" latinLnBrk="0" hangingPunct="1">
-              <a:lnSpc>
-                <a:spcPct val="100000"/>
-              </a:lnSpc>
-              <a:spcBef>
-                <a:spcPts val="0"/>
-              </a:spcBef>
-              <a:spcAft>
-                <a:spcPts val="0"/>
-              </a:spcAft>
-              <a:buClrTx/>
-              <a:buSzTx/>
-              <a:buFont typeface="Arial" panose="020B0604020202020204" pitchFamily="34" charset="0"/>
-              <a:buChar char="•"/>
-              <a:tabLst/>
-              <a:defRPr/>
-            </a:pPr>
-            <a:endParaRPr lang="en-PH" dirty="0"/>
-          </a:p>
-          <a:p>
-            <a:pPr marL="0" marR="0" lvl="0" indent="0" algn="l" defTabSz="914400" rtl="0" eaLnBrk="1" fontAlgn="auto" latinLnBrk="0" hangingPunct="1">
-              <a:lnSpc>
-                <a:spcPct val="100000"/>
-              </a:lnSpc>
-              <a:spcBef>
-                <a:spcPts val="0"/>
-              </a:spcBef>
-              <a:spcAft>
-                <a:spcPts val="0"/>
-              </a:spcAft>
-              <a:buClrTx/>
-              <a:buSzTx/>
-              <a:buFont typeface="Arial" panose="020B0604020202020204" pitchFamily="34" charset="0"/>
-              <a:buNone/>
-              <a:tabLst/>
-              <a:defRPr/>
-            </a:pPr>
             <a:endParaRPr lang="en-PH" dirty="0"/>
           </a:p>
         </p:txBody>
@@ -1550,7 +738,7 @@
           <a:p>
             <a:fld id="{BA95E93F-2514-4B81-921C-6961CBA23D3B}" type="slidenum">
               <a:rPr lang="en-PH" smtClean="0"/>
-              <a:t>21</a:t>
+              <a:t>18</a:t>
             </a:fld>
             <a:endParaRPr lang="en-PH"/>
           </a:p>
@@ -1559,7 +747,7 @@
     </p:spTree>
     <p:extLst>
       <p:ext uri="{BB962C8B-B14F-4D97-AF65-F5344CB8AC3E}">
-        <p14:creationId xmlns:p14="http://schemas.microsoft.com/office/powerpoint/2010/main" val="1744684742"/>
+        <p14:creationId xmlns:p14="http://schemas.microsoft.com/office/powerpoint/2010/main" val="963100552"/>
       </p:ext>
     </p:extLst>
   </p:cSld>
@@ -1613,10 +801,24 @@
           <a:bodyPr/>
           <a:lstStyle/>
           <a:p>
-            <a:r>
-              <a:rPr lang="en-PH" dirty="0"/>
-              <a:t>EBM – updates the probability based on the contribution of each feature</a:t>
-            </a:r>
+            <a:pPr marL="0" marR="0" lvl="0" indent="0" algn="l" defTabSz="914400" rtl="0" eaLnBrk="1" fontAlgn="auto" latinLnBrk="0" hangingPunct="1">
+              <a:lnSpc>
+                <a:spcPct val="100000"/>
+              </a:lnSpc>
+              <a:spcBef>
+                <a:spcPts val="0"/>
+              </a:spcBef>
+              <a:spcAft>
+                <a:spcPts val="0"/>
+              </a:spcAft>
+              <a:buClrTx/>
+              <a:buSzTx/>
+              <a:buFont typeface="Arial" panose="020B0604020202020204" pitchFamily="34" charset="0"/>
+              <a:buNone/>
+              <a:tabLst/>
+              <a:defRPr/>
+            </a:pPr>
+            <a:endParaRPr lang="en-PH" dirty="0"/>
           </a:p>
         </p:txBody>
       </p:sp>
@@ -1637,7 +839,7 @@
           <a:p>
             <a:fld id="{BA95E93F-2514-4B81-921C-6961CBA23D3B}" type="slidenum">
               <a:rPr lang="en-PH" smtClean="0"/>
-              <a:t>25</a:t>
+              <a:t>21</a:t>
             </a:fld>
             <a:endParaRPr lang="en-PH"/>
           </a:p>
@@ -1646,7 +848,7 @@
     </p:spTree>
     <p:extLst>
       <p:ext uri="{BB962C8B-B14F-4D97-AF65-F5344CB8AC3E}">
-        <p14:creationId xmlns:p14="http://schemas.microsoft.com/office/powerpoint/2010/main" val="1134256294"/>
+        <p14:creationId xmlns:p14="http://schemas.microsoft.com/office/powerpoint/2010/main" val="1744684742"/>
       </p:ext>
     </p:extLst>
   </p:cSld>
@@ -1702,26 +904,13 @@
           <a:p>
             <a:r>
               <a:rPr lang="en-US" dirty="0"/>
-              <a:t>PR-AUC ≈ 0.049 = the base rate. Zero lift over random guessing. </a:t>
+              <a:t>Why smote? Simpler and there are no harder boundaries to distinguish from EDA so ADASYN is not needed. </a:t>
             </a:r>
           </a:p>
           <a:p>
             <a:endParaRPr lang="en-US" dirty="0"/>
           </a:p>
           <a:p>
-            <a:r>
-              <a:rPr lang="en-US" dirty="0"/>
-              <a:t>Recall = 1.00 + Precision = 0.05 = every customer was flagged as a churner. That's not a model, that's just predicting "yes" for everyone. </a:t>
-            </a:r>
-          </a:p>
-          <a:p>
-            <a:endParaRPr lang="en-US" dirty="0"/>
-          </a:p>
-          <a:p>
-            <a:r>
-              <a:rPr lang="en-US" dirty="0"/>
-              <a:t>Thresholds of 0.01 mean the models found no meaningful probability to cut on. Three different model families, same failure → the problem is the data, not the model.</a:t>
-            </a:r>
             <a:endParaRPr lang="en-PH" dirty="0"/>
           </a:p>
         </p:txBody>
@@ -1743,7 +932,7 @@
           <a:p>
             <a:fld id="{BA95E93F-2514-4B81-921C-6961CBA23D3B}" type="slidenum">
               <a:rPr lang="en-PH" smtClean="0"/>
-              <a:t>27</a:t>
+              <a:t>22</a:t>
             </a:fld>
             <a:endParaRPr lang="en-PH"/>
           </a:p>
@@ -1752,7 +941,7 @@
     </p:spTree>
     <p:extLst>
       <p:ext uri="{BB962C8B-B14F-4D97-AF65-F5344CB8AC3E}">
-        <p14:creationId xmlns:p14="http://schemas.microsoft.com/office/powerpoint/2010/main" val="3654315476"/>
+        <p14:creationId xmlns:p14="http://schemas.microsoft.com/office/powerpoint/2010/main" val="913641487"/>
       </p:ext>
     </p:extLst>
   </p:cSld>
@@ -1806,6 +995,258 @@
           <a:bodyPr/>
           <a:lstStyle/>
           <a:p>
+            <a:endParaRPr lang="en-PH" dirty="0"/>
+          </a:p>
+        </p:txBody>
+      </p:sp>
+      <p:sp>
+        <p:nvSpPr>
+          <p:cNvPr id="4" name="Slide Number Placeholder 3"/>
+          <p:cNvSpPr>
+            <a:spLocks noGrp="1"/>
+          </p:cNvSpPr>
+          <p:nvPr>
+            <p:ph type="sldNum" sz="quarter" idx="5"/>
+          </p:nvPr>
+        </p:nvSpPr>
+        <p:spPr/>
+        <p:txBody>
+          <a:bodyPr/>
+          <a:lstStyle/>
+          <a:p>
+            <a:fld id="{BA95E93F-2514-4B81-921C-6961CBA23D3B}" type="slidenum">
+              <a:rPr lang="en-PH" smtClean="0"/>
+              <a:t>25</a:t>
+            </a:fld>
+            <a:endParaRPr lang="en-PH"/>
+          </a:p>
+        </p:txBody>
+      </p:sp>
+    </p:spTree>
+    <p:extLst>
+      <p:ext uri="{BB962C8B-B14F-4D97-AF65-F5344CB8AC3E}">
+        <p14:creationId xmlns:p14="http://schemas.microsoft.com/office/powerpoint/2010/main" val="1134256294"/>
+      </p:ext>
+    </p:extLst>
+  </p:cSld>
+  <p:clrMapOvr>
+    <a:masterClrMapping/>
+  </p:clrMapOvr>
+</p:notes>
+</file>
+
+<file path=ppt/notesSlides/notesSlide15.xml><?xml version="1.0" encoding="utf-8"?>
+<p:notes xmlns:a="http://schemas.openxmlformats.org/drawingml/2006/main" xmlns:r="http://schemas.openxmlformats.org/officeDocument/2006/relationships" xmlns:p="http://schemas.openxmlformats.org/presentationml/2006/main">
+  <p:cSld>
+    <p:spTree>
+      <p:nvGrpSpPr>
+        <p:cNvPr id="1" name=""/>
+        <p:cNvGrpSpPr/>
+        <p:nvPr/>
+      </p:nvGrpSpPr>
+      <p:grpSpPr>
+        <a:xfrm>
+          <a:off x="0" y="0"/>
+          <a:ext cx="0" cy="0"/>
+          <a:chOff x="0" y="0"/>
+          <a:chExt cx="0" cy="0"/>
+        </a:xfrm>
+      </p:grpSpPr>
+      <p:sp>
+        <p:nvSpPr>
+          <p:cNvPr id="2" name="Slide Image Placeholder 1"/>
+          <p:cNvSpPr>
+            <a:spLocks noGrp="1" noRot="1" noChangeAspect="1"/>
+          </p:cNvSpPr>
+          <p:nvPr>
+            <p:ph type="sldImg"/>
+          </p:nvPr>
+        </p:nvSpPr>
+        <p:spPr/>
+      </p:sp>
+      <p:sp>
+        <p:nvSpPr>
+          <p:cNvPr id="3" name="Notes Placeholder 2"/>
+          <p:cNvSpPr>
+            <a:spLocks noGrp="1"/>
+          </p:cNvSpPr>
+          <p:nvPr>
+            <p:ph type="body" idx="1"/>
+          </p:nvPr>
+        </p:nvSpPr>
+        <p:spPr/>
+        <p:txBody>
+          <a:bodyPr/>
+          <a:lstStyle/>
+          <a:p>
+            <a:endParaRPr lang="en-PH" dirty="0"/>
+          </a:p>
+        </p:txBody>
+      </p:sp>
+      <p:sp>
+        <p:nvSpPr>
+          <p:cNvPr id="4" name="Slide Number Placeholder 3"/>
+          <p:cNvSpPr>
+            <a:spLocks noGrp="1"/>
+          </p:cNvSpPr>
+          <p:nvPr>
+            <p:ph type="sldNum" sz="quarter" idx="5"/>
+          </p:nvPr>
+        </p:nvSpPr>
+        <p:spPr/>
+        <p:txBody>
+          <a:bodyPr/>
+          <a:lstStyle/>
+          <a:p>
+            <a:fld id="{BA95E93F-2514-4B81-921C-6961CBA23D3B}" type="slidenum">
+              <a:rPr lang="en-PH" smtClean="0"/>
+              <a:t>27</a:t>
+            </a:fld>
+            <a:endParaRPr lang="en-PH"/>
+          </a:p>
+        </p:txBody>
+      </p:sp>
+    </p:spTree>
+    <p:extLst>
+      <p:ext uri="{BB962C8B-B14F-4D97-AF65-F5344CB8AC3E}">
+        <p14:creationId xmlns:p14="http://schemas.microsoft.com/office/powerpoint/2010/main" val="3654315476"/>
+      </p:ext>
+    </p:extLst>
+  </p:cSld>
+  <p:clrMapOvr>
+    <a:masterClrMapping/>
+  </p:clrMapOvr>
+</p:notes>
+</file>
+
+<file path=ppt/notesSlides/notesSlide16.xml><?xml version="1.0" encoding="utf-8"?>
+<p:notes xmlns:a="http://schemas.openxmlformats.org/drawingml/2006/main" xmlns:r="http://schemas.openxmlformats.org/officeDocument/2006/relationships" xmlns:p="http://schemas.openxmlformats.org/presentationml/2006/main">
+  <p:cSld>
+    <p:spTree>
+      <p:nvGrpSpPr>
+        <p:cNvPr id="1" name=""/>
+        <p:cNvGrpSpPr/>
+        <p:nvPr/>
+      </p:nvGrpSpPr>
+      <p:grpSpPr>
+        <a:xfrm>
+          <a:off x="0" y="0"/>
+          <a:ext cx="0" cy="0"/>
+          <a:chOff x="0" y="0"/>
+          <a:chExt cx="0" cy="0"/>
+        </a:xfrm>
+      </p:grpSpPr>
+      <p:sp>
+        <p:nvSpPr>
+          <p:cNvPr id="2" name="Slide Image Placeholder 1"/>
+          <p:cNvSpPr>
+            <a:spLocks noGrp="1" noRot="1" noChangeAspect="1"/>
+          </p:cNvSpPr>
+          <p:nvPr>
+            <p:ph type="sldImg"/>
+          </p:nvPr>
+        </p:nvSpPr>
+        <p:spPr/>
+      </p:sp>
+      <p:sp>
+        <p:nvSpPr>
+          <p:cNvPr id="3" name="Notes Placeholder 2"/>
+          <p:cNvSpPr>
+            <a:spLocks noGrp="1"/>
+          </p:cNvSpPr>
+          <p:nvPr>
+            <p:ph type="body" idx="1"/>
+          </p:nvPr>
+        </p:nvSpPr>
+        <p:spPr/>
+        <p:txBody>
+          <a:bodyPr/>
+          <a:lstStyle/>
+          <a:p>
+            <a:endParaRPr lang="en-PH" dirty="0"/>
+          </a:p>
+        </p:txBody>
+      </p:sp>
+      <p:sp>
+        <p:nvSpPr>
+          <p:cNvPr id="4" name="Slide Number Placeholder 3"/>
+          <p:cNvSpPr>
+            <a:spLocks noGrp="1"/>
+          </p:cNvSpPr>
+          <p:nvPr>
+            <p:ph type="sldNum" sz="quarter" idx="5"/>
+          </p:nvPr>
+        </p:nvSpPr>
+        <p:spPr/>
+        <p:txBody>
+          <a:bodyPr/>
+          <a:lstStyle/>
+          <a:p>
+            <a:fld id="{BA95E93F-2514-4B81-921C-6961CBA23D3B}" type="slidenum">
+              <a:rPr lang="en-PH" smtClean="0"/>
+              <a:t>31</a:t>
+            </a:fld>
+            <a:endParaRPr lang="en-PH"/>
+          </a:p>
+        </p:txBody>
+      </p:sp>
+    </p:spTree>
+    <p:extLst>
+      <p:ext uri="{BB962C8B-B14F-4D97-AF65-F5344CB8AC3E}">
+        <p14:creationId xmlns:p14="http://schemas.microsoft.com/office/powerpoint/2010/main" val="548497932"/>
+      </p:ext>
+    </p:extLst>
+  </p:cSld>
+  <p:clrMapOvr>
+    <a:masterClrMapping/>
+  </p:clrMapOvr>
+</p:notes>
+</file>
+
+<file path=ppt/notesSlides/notesSlide17.xml><?xml version="1.0" encoding="utf-8"?>
+<p:notes xmlns:a="http://schemas.openxmlformats.org/drawingml/2006/main" xmlns:r="http://schemas.openxmlformats.org/officeDocument/2006/relationships" xmlns:p="http://schemas.openxmlformats.org/presentationml/2006/main">
+  <p:cSld>
+    <p:spTree>
+      <p:nvGrpSpPr>
+        <p:cNvPr id="1" name=""/>
+        <p:cNvGrpSpPr/>
+        <p:nvPr/>
+      </p:nvGrpSpPr>
+      <p:grpSpPr>
+        <a:xfrm>
+          <a:off x="0" y="0"/>
+          <a:ext cx="0" cy="0"/>
+          <a:chOff x="0" y="0"/>
+          <a:chExt cx="0" cy="0"/>
+        </a:xfrm>
+      </p:grpSpPr>
+      <p:sp>
+        <p:nvSpPr>
+          <p:cNvPr id="2" name="Slide Image Placeholder 1"/>
+          <p:cNvSpPr>
+            <a:spLocks noGrp="1" noRot="1" noChangeAspect="1"/>
+          </p:cNvSpPr>
+          <p:nvPr>
+            <p:ph type="sldImg"/>
+          </p:nvPr>
+        </p:nvSpPr>
+        <p:spPr/>
+      </p:sp>
+      <p:sp>
+        <p:nvSpPr>
+          <p:cNvPr id="3" name="Notes Placeholder 2"/>
+          <p:cNvSpPr>
+            <a:spLocks noGrp="1"/>
+          </p:cNvSpPr>
+          <p:nvPr>
+            <p:ph type="body" idx="1"/>
+          </p:nvPr>
+        </p:nvSpPr>
+        <p:spPr/>
+        <p:txBody>
+          <a:bodyPr/>
+          <a:lstStyle/>
+          <a:p>
             <a:pPr marL="0" marR="0" lvl="0" indent="0" algn="l" defTabSz="914400" rtl="0" eaLnBrk="1" fontAlgn="auto" latinLnBrk="0" hangingPunct="1">
               <a:lnSpc>
                 <a:spcPct val="100000"/>
@@ -1880,7 +1321,7 @@
 </p:notes>
 </file>
 
-<file path=ppt/notesSlides/notesSlide15.xml><?xml version="1.0" encoding="utf-8"?>
+<file path=ppt/notesSlides/notesSlide18.xml><?xml version="1.0" encoding="utf-8"?>
 <p:notes xmlns:a="http://schemas.openxmlformats.org/drawingml/2006/main" xmlns:r="http://schemas.openxmlformats.org/officeDocument/2006/relationships" xmlns:p="http://schemas.openxmlformats.org/presentationml/2006/main">
   <p:cSld>
     <p:spTree>
@@ -2060,43 +1501,6 @@
           <a:bodyPr/>
           <a:lstStyle/>
           <a:p>
-            <a:r>
-              <a:rPr lang="en-PH" dirty="0" err="1"/>
-              <a:t>Winsorization</a:t>
-            </a:r>
-            <a:r>
-              <a:rPr lang="en-PH" dirty="0"/>
-              <a:t> – conservative rather than removal of outliers.</a:t>
-            </a:r>
-          </a:p>
-          <a:p>
-            <a:endParaRPr lang="en-PH" dirty="0"/>
-          </a:p>
-          <a:p>
-            <a:pPr marL="171450" indent="-171450">
-              <a:buFont typeface="Arial" panose="020B0604020202020204" pitchFamily="34" charset="0"/>
-              <a:buChar char="•"/>
-            </a:pPr>
-            <a:r>
-              <a:rPr lang="en-PH" dirty="0"/>
-              <a:t>Any value greater than Q3 (75%) -&gt; replaced by Q3 value</a:t>
-            </a:r>
-          </a:p>
-          <a:p>
-            <a:pPr marL="171450" indent="-171450">
-              <a:buFont typeface="Arial" panose="020B0604020202020204" pitchFamily="34" charset="0"/>
-              <a:buChar char="•"/>
-            </a:pPr>
-            <a:r>
-              <a:rPr lang="en-PH" dirty="0"/>
-              <a:t>Any value less than Q1 (25%) -&gt; replaced by Q1 value</a:t>
-            </a:r>
-          </a:p>
-          <a:p>
-            <a:pPr marL="0" indent="0">
-              <a:buFont typeface="Arial" panose="020B0604020202020204" pitchFamily="34" charset="0"/>
-              <a:buNone/>
-            </a:pPr>
             <a:endParaRPr lang="en-PH" dirty="0"/>
           </a:p>
         </p:txBody>
@@ -2118,7 +1522,7 @@
           <a:p>
             <a:fld id="{BA95E93F-2514-4B81-921C-6961CBA23D3B}" type="slidenum">
               <a:rPr lang="en-PH" smtClean="0"/>
-              <a:t>8</a:t>
+              <a:t>7</a:t>
             </a:fld>
             <a:endParaRPr lang="en-PH"/>
           </a:p>
@@ -2127,7 +1531,7 @@
     </p:spTree>
     <p:extLst>
       <p:ext uri="{BB962C8B-B14F-4D97-AF65-F5344CB8AC3E}">
-        <p14:creationId xmlns:p14="http://schemas.microsoft.com/office/powerpoint/2010/main" val="91428300"/>
+        <p14:creationId xmlns:p14="http://schemas.microsoft.com/office/powerpoint/2010/main" val="3500500661"/>
       </p:ext>
     </p:extLst>
   </p:cSld>
@@ -2181,75 +1585,11 @@
           <a:bodyPr/>
           <a:lstStyle/>
           <a:p>
-            <a:r>
-              <a:rPr lang="en-PH" dirty="0"/>
-              <a:t>Median imputation – preferred over mean to prevent outlier pull </a:t>
-            </a:r>
-          </a:p>
-          <a:p>
-            <a:endParaRPr lang="en-PH" dirty="0"/>
-          </a:p>
-          <a:p>
-            <a:r>
-              <a:rPr lang="en-PH" dirty="0"/>
-              <a:t>High cardinality – Bayesian target encoding, robust to outliers. Uses sigmoid function with Min samples leaf = 20 (smoothing) as criteria. </a:t>
-            </a:r>
-          </a:p>
-          <a:p>
-            <a:endParaRPr lang="en-PH" dirty="0"/>
-          </a:p>
-          <a:p>
-            <a:pPr marL="171450" indent="-171450">
+            <a:pPr marL="0" indent="0">
               <a:buFont typeface="Arial" panose="020B0604020202020204" pitchFamily="34" charset="0"/>
-              <a:buChar char="•"/>
-            </a:pPr>
-            <a:r>
-              <a:rPr lang="en-PH" dirty="0"/>
-              <a:t>Prior: If country sample &lt; 20, use global mean (e.g. outliers)</a:t>
-            </a:r>
-          </a:p>
-          <a:p>
-            <a:endParaRPr lang="en-PH" dirty="0"/>
-          </a:p>
-          <a:p>
-            <a:pPr marL="171450" indent="-171450">
-              <a:buFont typeface="Arial" panose="020B0604020202020204" pitchFamily="34" charset="0"/>
-              <a:buChar char="•"/>
-            </a:pPr>
-            <a:r>
-              <a:rPr lang="en-PH" dirty="0"/>
-              <a:t>If n = 20, local rate + global rate</a:t>
-            </a:r>
-          </a:p>
-          <a:p>
-            <a:endParaRPr lang="en-PH" dirty="0"/>
-          </a:p>
-          <a:p>
-            <a:pPr marL="171450" indent="-171450">
-              <a:buFont typeface="Arial" panose="020B0604020202020204" pitchFamily="34" charset="0"/>
-              <a:buChar char="•"/>
-            </a:pPr>
-            <a:r>
-              <a:rPr lang="en-PH" dirty="0"/>
-              <a:t>Posterior: If n &gt; 20, local rate</a:t>
-            </a:r>
-          </a:p>
-          <a:p>
-            <a:pPr marL="171450" indent="-171450">
-              <a:buFont typeface="Arial" panose="020B0604020202020204" pitchFamily="34" charset="0"/>
-              <a:buChar char="•"/>
+              <a:buNone/>
             </a:pPr>
             <a:endParaRPr lang="en-PH" dirty="0"/>
-          </a:p>
-          <a:p>
-            <a:pPr marL="171450" indent="-171450">
-              <a:buFont typeface="Arial" panose="020B0604020202020204" pitchFamily="34" charset="0"/>
-              <a:buChar char="•"/>
-            </a:pPr>
-            <a:r>
-              <a:rPr lang="en-PH" dirty="0"/>
-              <a:t>This way, overfitting is prevented for small samples.</a:t>
-            </a:r>
           </a:p>
         </p:txBody>
       </p:sp>
@@ -2270,7 +1610,7 @@
           <a:p>
             <a:fld id="{BA95E93F-2514-4B81-921C-6961CBA23D3B}" type="slidenum">
               <a:rPr lang="en-PH" smtClean="0"/>
-              <a:t>9</a:t>
+              <a:t>8</a:t>
             </a:fld>
             <a:endParaRPr lang="en-PH"/>
           </a:p>
@@ -2279,7 +1619,7 @@
     </p:spTree>
     <p:extLst>
       <p:ext uri="{BB962C8B-B14F-4D97-AF65-F5344CB8AC3E}">
-        <p14:creationId xmlns:p14="http://schemas.microsoft.com/office/powerpoint/2010/main" val="1791892605"/>
+        <p14:creationId xmlns:p14="http://schemas.microsoft.com/office/powerpoint/2010/main" val="91428300"/>
       </p:ext>
     </p:extLst>
   </p:cSld>
@@ -2333,449 +1673,6 @@
           <a:bodyPr/>
           <a:lstStyle/>
           <a:p>
-            <a:pPr marL="0" marR="0" lvl="0" indent="0" algn="l" defTabSz="914400" rtl="0" eaLnBrk="1" fontAlgn="auto" latinLnBrk="0" hangingPunct="1">
-              <a:lnSpc>
-                <a:spcPct val="100000"/>
-              </a:lnSpc>
-              <a:spcBef>
-                <a:spcPts val="0"/>
-              </a:spcBef>
-              <a:spcAft>
-                <a:spcPts val="0"/>
-              </a:spcAft>
-              <a:buClrTx/>
-              <a:buSzTx/>
-              <a:buFontTx/>
-              <a:buNone/>
-              <a:tabLst/>
-              <a:defRPr/>
-            </a:pPr>
-            <a:r>
-              <a:rPr lang="en-US" sz="1200" b="1" i="0" kern="1200" dirty="0">
-                <a:solidFill>
-                  <a:schemeClr val="tx1"/>
-                </a:solidFill>
-                <a:effectLst/>
-                <a:latin typeface="+mn-lt"/>
-                <a:ea typeface="+mn-ea"/>
-                <a:cs typeface="+mn-cs"/>
-              </a:rPr>
-              <a:t>Rather than using boxplots, show via statistics if there’s diff of attrition across groups</a:t>
-            </a:r>
-          </a:p>
-          <a:p>
-            <a:pPr marL="0" marR="0" lvl="0" indent="0" algn="l" defTabSz="914400" rtl="0" eaLnBrk="1" fontAlgn="auto" latinLnBrk="0" hangingPunct="1">
-              <a:lnSpc>
-                <a:spcPct val="100000"/>
-              </a:lnSpc>
-              <a:spcBef>
-                <a:spcPts val="0"/>
-              </a:spcBef>
-              <a:spcAft>
-                <a:spcPts val="0"/>
-              </a:spcAft>
-              <a:buClrTx/>
-              <a:buSzTx/>
-              <a:buFontTx/>
-              <a:buNone/>
-              <a:tabLst/>
-              <a:defRPr/>
-            </a:pPr>
-            <a:endParaRPr lang="en-US" sz="1200" b="1" i="0" kern="1200" dirty="0">
-              <a:solidFill>
-                <a:schemeClr val="tx1"/>
-              </a:solidFill>
-              <a:effectLst/>
-              <a:latin typeface="+mn-lt"/>
-              <a:ea typeface="+mn-ea"/>
-              <a:cs typeface="+mn-cs"/>
-            </a:endParaRPr>
-          </a:p>
-          <a:p>
-            <a:pPr marL="0" marR="0" lvl="0" indent="0" algn="l" defTabSz="914400" rtl="0" eaLnBrk="1" fontAlgn="auto" latinLnBrk="0" hangingPunct="1">
-              <a:lnSpc>
-                <a:spcPct val="100000"/>
-              </a:lnSpc>
-              <a:spcBef>
-                <a:spcPts val="0"/>
-              </a:spcBef>
-              <a:spcAft>
-                <a:spcPts val="0"/>
-              </a:spcAft>
-              <a:buClrTx/>
-              <a:buSzTx/>
-              <a:buFontTx/>
-              <a:buNone/>
-              <a:tabLst/>
-              <a:defRPr/>
-            </a:pPr>
-            <a:r>
-              <a:rPr lang="en-US" sz="1200" b="1" i="0" kern="1200" dirty="0">
-                <a:solidFill>
-                  <a:schemeClr val="tx1"/>
-                </a:solidFill>
-                <a:effectLst/>
-                <a:latin typeface="+mn-lt"/>
-                <a:ea typeface="+mn-ea"/>
-                <a:cs typeface="+mn-cs"/>
-              </a:rPr>
-              <a:t>Categorical – </a:t>
-            </a:r>
-            <a:r>
-              <a:rPr lang="en-US" sz="1200" b="1" i="0" kern="1200" dirty="0" err="1">
-                <a:solidFill>
-                  <a:schemeClr val="tx1"/>
-                </a:solidFill>
-                <a:effectLst/>
-                <a:latin typeface="+mn-lt"/>
-                <a:ea typeface="+mn-ea"/>
-                <a:cs typeface="+mn-cs"/>
-              </a:rPr>
-              <a:t>Chisq</a:t>
-            </a:r>
-            <a:r>
-              <a:rPr lang="en-US" sz="1200" b="1" i="0" kern="1200" dirty="0">
-                <a:solidFill>
-                  <a:schemeClr val="tx1"/>
-                </a:solidFill>
-                <a:effectLst/>
-                <a:latin typeface="+mn-lt"/>
-                <a:ea typeface="+mn-ea"/>
-                <a:cs typeface="+mn-cs"/>
-              </a:rPr>
-              <a:t> (diff of churn across groups real?) + </a:t>
-            </a:r>
-            <a:r>
-              <a:rPr lang="en-US" sz="1200" b="1" i="0" kern="1200" dirty="0" err="1">
-                <a:solidFill>
-                  <a:schemeClr val="tx1"/>
-                </a:solidFill>
-                <a:effectLst/>
-                <a:latin typeface="+mn-lt"/>
-                <a:ea typeface="+mn-ea"/>
-                <a:cs typeface="+mn-cs"/>
-              </a:rPr>
-              <a:t>cramer’s</a:t>
-            </a:r>
-            <a:r>
-              <a:rPr lang="en-US" sz="1200" b="1" i="0" kern="1200" dirty="0">
-                <a:solidFill>
-                  <a:schemeClr val="tx1"/>
-                </a:solidFill>
-                <a:effectLst/>
-                <a:latin typeface="+mn-lt"/>
-                <a:ea typeface="+mn-ea"/>
-                <a:cs typeface="+mn-cs"/>
-              </a:rPr>
-              <a:t> (how strong)</a:t>
-            </a:r>
-          </a:p>
-          <a:p>
-            <a:pPr marL="0" marR="0" lvl="0" indent="0" algn="l" defTabSz="914400" rtl="0" eaLnBrk="1" fontAlgn="auto" latinLnBrk="0" hangingPunct="1">
-              <a:lnSpc>
-                <a:spcPct val="100000"/>
-              </a:lnSpc>
-              <a:spcBef>
-                <a:spcPts val="0"/>
-              </a:spcBef>
-              <a:spcAft>
-                <a:spcPts val="0"/>
-              </a:spcAft>
-              <a:buClrTx/>
-              <a:buSzTx/>
-              <a:buFontTx/>
-              <a:buNone/>
-              <a:tabLst/>
-              <a:defRPr/>
-            </a:pPr>
-            <a:endParaRPr lang="en-US" sz="1200" b="1" i="0" kern="1200" dirty="0">
-              <a:solidFill>
-                <a:schemeClr val="tx1"/>
-              </a:solidFill>
-              <a:effectLst/>
-              <a:latin typeface="+mn-lt"/>
-              <a:ea typeface="+mn-ea"/>
-              <a:cs typeface="+mn-cs"/>
-            </a:endParaRPr>
-          </a:p>
-          <a:p>
-            <a:pPr marL="0" marR="0" lvl="0" indent="0" algn="l" defTabSz="914400" rtl="0" eaLnBrk="1" fontAlgn="auto" latinLnBrk="0" hangingPunct="1">
-              <a:lnSpc>
-                <a:spcPct val="100000"/>
-              </a:lnSpc>
-              <a:spcBef>
-                <a:spcPts val="0"/>
-              </a:spcBef>
-              <a:spcAft>
-                <a:spcPts val="0"/>
-              </a:spcAft>
-              <a:buClrTx/>
-              <a:buSzTx/>
-              <a:buFontTx/>
-              <a:buNone/>
-              <a:tabLst/>
-              <a:defRPr/>
-            </a:pPr>
-            <a:r>
-              <a:rPr lang="en-US" sz="1200" b="1" i="0" kern="1200" dirty="0">
-                <a:solidFill>
-                  <a:schemeClr val="tx1"/>
-                </a:solidFill>
-                <a:effectLst/>
-                <a:latin typeface="+mn-lt"/>
-                <a:ea typeface="+mn-ea"/>
-                <a:cs typeface="+mn-cs"/>
-              </a:rPr>
-              <a:t>Chi-square test  - is the difference in churn rates across groups real or random noise?</a:t>
-            </a:r>
-          </a:p>
-          <a:p>
-            <a:pPr marL="0" marR="0" lvl="0" indent="0" algn="l" defTabSz="914400" rtl="0" eaLnBrk="1" fontAlgn="auto" latinLnBrk="0" hangingPunct="1">
-              <a:lnSpc>
-                <a:spcPct val="100000"/>
-              </a:lnSpc>
-              <a:spcBef>
-                <a:spcPts val="0"/>
-              </a:spcBef>
-              <a:spcAft>
-                <a:spcPts val="0"/>
-              </a:spcAft>
-              <a:buClrTx/>
-              <a:buSzTx/>
-              <a:buFontTx/>
-              <a:buNone/>
-              <a:tabLst/>
-              <a:defRPr/>
-            </a:pPr>
-            <a:endParaRPr lang="en-US" sz="1200" b="1" i="0" kern="1200" dirty="0">
-              <a:solidFill>
-                <a:schemeClr val="tx1"/>
-              </a:solidFill>
-              <a:effectLst/>
-              <a:latin typeface="+mn-lt"/>
-              <a:ea typeface="+mn-ea"/>
-              <a:cs typeface="+mn-cs"/>
-            </a:endParaRPr>
-          </a:p>
-          <a:p>
-            <a:r>
-              <a:rPr lang="en-US" sz="1200" b="0" i="0" kern="1200" dirty="0">
-                <a:solidFill>
-                  <a:schemeClr val="tx1"/>
-                </a:solidFill>
-                <a:effectLst/>
-                <a:latin typeface="+mn-lt"/>
-                <a:ea typeface="+mn-ea"/>
-                <a:cs typeface="+mn-cs"/>
-              </a:rPr>
-              <a:t>Build a contingency table: counts of churners and stayers per category (e.g. Male/Female × Churned/Stayed)</a:t>
-            </a:r>
-          </a:p>
-          <a:p>
-            <a:r>
-              <a:rPr lang="en-US" sz="1200" b="0" i="0" kern="1200" dirty="0">
-                <a:solidFill>
-                  <a:schemeClr val="tx1"/>
-                </a:solidFill>
-                <a:effectLst/>
-                <a:latin typeface="+mn-lt"/>
-                <a:ea typeface="+mn-ea"/>
-                <a:cs typeface="+mn-cs"/>
-              </a:rPr>
-              <a:t>Expected count = (Row Total × Column Total) / Grand Total</a:t>
-            </a:r>
-          </a:p>
-          <a:p>
-            <a:r>
-              <a:rPr lang="en-US" sz="1200" b="0" i="0" kern="1200" dirty="0">
-                <a:solidFill>
-                  <a:schemeClr val="tx1"/>
-                </a:solidFill>
-                <a:effectLst/>
-                <a:latin typeface="+mn-lt"/>
-                <a:ea typeface="+mn-ea"/>
-                <a:cs typeface="+mn-cs"/>
-              </a:rPr>
-              <a:t>χ² = Σ (Observed − Expected)² / Expected — summed across every cell in the table</a:t>
-            </a:r>
-          </a:p>
-          <a:p>
-            <a:pPr marL="0" marR="0" lvl="0" indent="0" algn="l" defTabSz="914400" rtl="0" eaLnBrk="1" fontAlgn="auto" latinLnBrk="0" hangingPunct="1">
-              <a:lnSpc>
-                <a:spcPct val="100000"/>
-              </a:lnSpc>
-              <a:spcBef>
-                <a:spcPts val="0"/>
-              </a:spcBef>
-              <a:spcAft>
-                <a:spcPts val="0"/>
-              </a:spcAft>
-              <a:buClrTx/>
-              <a:buSzTx/>
-              <a:buFontTx/>
-              <a:buNone/>
-              <a:tabLst/>
-              <a:defRPr/>
-            </a:pPr>
-            <a:endParaRPr lang="en-US" sz="1200" b="0" i="0" kern="1200" dirty="0">
-              <a:solidFill>
-                <a:schemeClr val="tx1"/>
-              </a:solidFill>
-              <a:effectLst/>
-              <a:latin typeface="+mn-lt"/>
-              <a:ea typeface="+mn-ea"/>
-              <a:cs typeface="+mn-cs"/>
-            </a:endParaRPr>
-          </a:p>
-          <a:p>
-            <a:pPr marL="0" marR="0" lvl="0" indent="0" algn="l" defTabSz="914400" rtl="0" eaLnBrk="1" fontAlgn="auto" latinLnBrk="0" hangingPunct="1">
-              <a:lnSpc>
-                <a:spcPct val="100000"/>
-              </a:lnSpc>
-              <a:spcBef>
-                <a:spcPts val="0"/>
-              </a:spcBef>
-              <a:spcAft>
-                <a:spcPts val="0"/>
-              </a:spcAft>
-              <a:buClrTx/>
-              <a:buSzTx/>
-              <a:buFontTx/>
-              <a:buNone/>
-              <a:tabLst/>
-              <a:defRPr/>
-            </a:pPr>
-            <a:r>
-              <a:rPr lang="en-US" sz="1200" b="0" i="0" kern="1200" dirty="0">
-                <a:solidFill>
-                  <a:schemeClr val="tx1"/>
-                </a:solidFill>
-                <a:effectLst/>
-                <a:latin typeface="+mn-lt"/>
-                <a:ea typeface="+mn-ea"/>
-                <a:cs typeface="+mn-cs"/>
-              </a:rPr>
-              <a:t>p = 0.430 → 43% chance the difference between churners and stayers on gender is just random noise. Way above the 0.05 threshold.</a:t>
-            </a:r>
-          </a:p>
-          <a:p>
-            <a:pPr marL="0" marR="0" lvl="0" indent="0" algn="l" defTabSz="914400" rtl="0" eaLnBrk="1" fontAlgn="auto" latinLnBrk="0" hangingPunct="1">
-              <a:lnSpc>
-                <a:spcPct val="100000"/>
-              </a:lnSpc>
-              <a:spcBef>
-                <a:spcPts val="0"/>
-              </a:spcBef>
-              <a:spcAft>
-                <a:spcPts val="0"/>
-              </a:spcAft>
-              <a:buClrTx/>
-              <a:buSzTx/>
-              <a:buFontTx/>
-              <a:buNone/>
-              <a:tabLst/>
-              <a:defRPr/>
-            </a:pPr>
-            <a:endParaRPr lang="en-US" sz="1200" b="0" i="0" kern="1200" dirty="0">
-              <a:solidFill>
-                <a:schemeClr val="tx1"/>
-              </a:solidFill>
-              <a:effectLst/>
-              <a:latin typeface="+mn-lt"/>
-              <a:ea typeface="+mn-ea"/>
-              <a:cs typeface="+mn-cs"/>
-            </a:endParaRPr>
-          </a:p>
-          <a:p>
-            <a:r>
-              <a:rPr lang="en-US" sz="1200" b="1" i="0" kern="1200" dirty="0">
-                <a:solidFill>
-                  <a:schemeClr val="tx1"/>
-                </a:solidFill>
-                <a:effectLst/>
-                <a:latin typeface="+mn-lt"/>
-                <a:ea typeface="+mn-ea"/>
-                <a:cs typeface="+mn-cs"/>
-              </a:rPr>
-              <a:t>Cramér's V — if real, </a:t>
-            </a:r>
-            <a:r>
-              <a:rPr lang="en-US" sz="1200" b="1" i="0" kern="1200" dirty="0" err="1">
-                <a:solidFill>
-                  <a:schemeClr val="tx1"/>
-                </a:solidFill>
-                <a:effectLst/>
-                <a:latin typeface="+mn-lt"/>
-                <a:ea typeface="+mn-ea"/>
-                <a:cs typeface="+mn-cs"/>
-              </a:rPr>
-              <a:t>whats</a:t>
-            </a:r>
-            <a:r>
-              <a:rPr lang="en-US" sz="1200" b="1" i="0" kern="1200" dirty="0">
-                <a:solidFill>
-                  <a:schemeClr val="tx1"/>
-                </a:solidFill>
-                <a:effectLst/>
-                <a:latin typeface="+mn-lt"/>
-                <a:ea typeface="+mn-ea"/>
-                <a:cs typeface="+mn-cs"/>
-              </a:rPr>
-              <a:t> the strength of association? </a:t>
-            </a:r>
-            <a:endParaRPr lang="en-US" sz="1200" b="0" i="0" kern="1200" dirty="0">
-              <a:solidFill>
-                <a:schemeClr val="tx1"/>
-              </a:solidFill>
-              <a:effectLst/>
-              <a:latin typeface="+mn-lt"/>
-              <a:ea typeface="+mn-ea"/>
-              <a:cs typeface="+mn-cs"/>
-            </a:endParaRPr>
-          </a:p>
-          <a:p>
-            <a:r>
-              <a:rPr lang="en-US" sz="1200" b="0" i="0" kern="1200" dirty="0">
-                <a:solidFill>
-                  <a:schemeClr val="tx1"/>
-                </a:solidFill>
-                <a:effectLst/>
-                <a:latin typeface="+mn-lt"/>
-                <a:ea typeface="+mn-ea"/>
-                <a:cs typeface="+mn-cs"/>
-              </a:rPr>
-              <a:t>Normalizes χ² so large sample sizes don't inflate the result</a:t>
-            </a:r>
-          </a:p>
-          <a:p>
-            <a:r>
-              <a:rPr lang="en-US" sz="1200" b="0" i="0" kern="1200" dirty="0">
-                <a:solidFill>
-                  <a:schemeClr val="tx1"/>
-                </a:solidFill>
-                <a:effectLst/>
-                <a:latin typeface="+mn-lt"/>
-                <a:ea typeface="+mn-ea"/>
-                <a:cs typeface="+mn-cs"/>
-              </a:rPr>
-              <a:t>V = √( χ² / (n × min(rows−1, cols−1)) )</a:t>
-            </a:r>
-          </a:p>
-          <a:p>
-            <a:r>
-              <a:rPr lang="en-US" sz="1200" b="0" i="0" kern="1200" dirty="0">
-                <a:solidFill>
-                  <a:schemeClr val="tx1"/>
-                </a:solidFill>
-                <a:effectLst/>
-                <a:latin typeface="+mn-lt"/>
-                <a:ea typeface="+mn-ea"/>
-                <a:cs typeface="+mn-cs"/>
-              </a:rPr>
-              <a:t>&lt; 0.1: Negligible; 0.1–0.3: Small; 0.3–0.5: Medium; &gt; 0.5: Large</a:t>
-            </a:r>
-          </a:p>
-          <a:p>
             <a:endParaRPr lang="en-PH" dirty="0"/>
           </a:p>
         </p:txBody>
@@ -2797,7 +1694,7 @@
           <a:p>
             <a:fld id="{BA95E93F-2514-4B81-921C-6961CBA23D3B}" type="slidenum">
               <a:rPr lang="en-PH" smtClean="0"/>
-              <a:t>10</a:t>
+              <a:t>9</a:t>
             </a:fld>
             <a:endParaRPr lang="en-PH"/>
           </a:p>
@@ -2806,7 +1703,7 @@
     </p:spTree>
     <p:extLst>
       <p:ext uri="{BB962C8B-B14F-4D97-AF65-F5344CB8AC3E}">
-        <p14:creationId xmlns:p14="http://schemas.microsoft.com/office/powerpoint/2010/main" val="2083346032"/>
+        <p14:creationId xmlns:p14="http://schemas.microsoft.com/office/powerpoint/2010/main" val="1791892605"/>
       </p:ext>
     </p:extLst>
   </p:cSld>
@@ -2860,168 +1757,89 @@
           <a:bodyPr/>
           <a:lstStyle/>
           <a:p>
-            <a:r>
-              <a:rPr lang="en-PH" b="1" dirty="0"/>
-              <a:t>Numerical – Welch’s (</a:t>
-            </a:r>
-          </a:p>
-          <a:p>
-            <a:endParaRPr lang="en-PH" b="1" dirty="0"/>
-          </a:p>
-          <a:p>
-            <a:r>
-              <a:rPr lang="en-PH" b="1" dirty="0"/>
-              <a:t>Welch’s t-test – is the diff of </a:t>
-            </a:r>
-            <a:r>
-              <a:rPr lang="en-PH" b="1" dirty="0" err="1"/>
-              <a:t>attriters</a:t>
-            </a:r>
-            <a:r>
-              <a:rPr lang="en-PH" b="1" dirty="0"/>
-              <a:t> and stayers real or regular noise? </a:t>
-            </a:r>
-          </a:p>
-          <a:p>
             <a:endParaRPr lang="en-PH" dirty="0"/>
           </a:p>
-          <a:p>
-            <a:r>
-              <a:rPr lang="en-PH" dirty="0"/>
-              <a:t>regular t-test assumes equal variance so </a:t>
-            </a:r>
-            <a:r>
-              <a:rPr lang="en-PH" dirty="0" err="1"/>
-              <a:t>equal_var</a:t>
-            </a:r>
-            <a:r>
-              <a:rPr lang="en-PH" dirty="0"/>
-              <a:t> = False. </a:t>
-            </a:r>
-          </a:p>
-          <a:p>
-            <a:endParaRPr lang="en-PH" dirty="0"/>
-          </a:p>
-          <a:p>
-            <a:pPr marL="171450" indent="-171450">
-              <a:buFont typeface="Arial" panose="020B0604020202020204" pitchFamily="34" charset="0"/>
-              <a:buChar char="•"/>
-            </a:pPr>
-            <a:r>
-              <a:rPr lang="en-PH" dirty="0"/>
-              <a:t>Considers var of churners (s1) and var of stayers (s2) per feature (var = (x – mean)^2 / (n -1))</a:t>
-            </a:r>
-          </a:p>
-          <a:p>
-            <a:pPr marL="171450" marR="0" lvl="0" indent="-171450" algn="l" defTabSz="914400" rtl="0" eaLnBrk="1" fontAlgn="auto" latinLnBrk="0" hangingPunct="1">
-              <a:lnSpc>
-                <a:spcPct val="100000"/>
-              </a:lnSpc>
-              <a:spcBef>
-                <a:spcPts val="0"/>
-              </a:spcBef>
-              <a:spcAft>
-                <a:spcPts val="0"/>
-              </a:spcAft>
-              <a:buClrTx/>
-              <a:buSzTx/>
-              <a:buFont typeface="Arial" panose="020B0604020202020204" pitchFamily="34" charset="0"/>
-              <a:buChar char="•"/>
-              <a:tabLst/>
-              <a:defRPr/>
-            </a:pPr>
-            <a:r>
-              <a:rPr lang="en-PH" sz="1200" b="0" i="0" kern="1200" dirty="0">
-                <a:solidFill>
-                  <a:schemeClr val="tx1"/>
-                </a:solidFill>
-                <a:effectLst/>
-                <a:latin typeface="+mn-lt"/>
-                <a:ea typeface="+mn-ea"/>
-                <a:cs typeface="+mn-cs"/>
-              </a:rPr>
-              <a:t>SE = √( s₁²/n₁  +  s₂²/n₂ )</a:t>
-            </a:r>
-          </a:p>
-          <a:p>
-            <a:pPr marL="171450" marR="0" lvl="0" indent="-171450" algn="l" defTabSz="914400" rtl="0" eaLnBrk="1" fontAlgn="auto" latinLnBrk="0" hangingPunct="1">
-              <a:lnSpc>
-                <a:spcPct val="100000"/>
-              </a:lnSpc>
-              <a:spcBef>
-                <a:spcPts val="0"/>
-              </a:spcBef>
-              <a:spcAft>
-                <a:spcPts val="0"/>
-              </a:spcAft>
-              <a:buClrTx/>
-              <a:buSzTx/>
-              <a:buFont typeface="Arial" panose="020B0604020202020204" pitchFamily="34" charset="0"/>
-              <a:buChar char="•"/>
-              <a:tabLst/>
-              <a:defRPr/>
-            </a:pPr>
-            <a:r>
-              <a:rPr lang="en-PH" sz="1200" b="0" i="0" kern="1200" dirty="0">
-                <a:solidFill>
-                  <a:schemeClr val="tx1"/>
-                </a:solidFill>
-                <a:effectLst/>
-                <a:latin typeface="+mn-lt"/>
-                <a:ea typeface="+mn-ea"/>
-                <a:cs typeface="+mn-cs"/>
-              </a:rPr>
-              <a:t>Welch T-test = (</a:t>
-            </a:r>
-            <a:r>
-              <a:rPr lang="en-PH" sz="1200" b="0" i="0" kern="1200" dirty="0" err="1">
-                <a:solidFill>
-                  <a:schemeClr val="tx1"/>
-                </a:solidFill>
-                <a:effectLst/>
-                <a:latin typeface="+mn-lt"/>
-                <a:ea typeface="+mn-ea"/>
-                <a:cs typeface="+mn-cs"/>
-              </a:rPr>
-              <a:t>mean_stayers</a:t>
-            </a:r>
-            <a:r>
-              <a:rPr lang="en-PH" sz="1200" b="0" i="0" kern="1200" dirty="0">
-                <a:solidFill>
-                  <a:schemeClr val="tx1"/>
-                </a:solidFill>
-                <a:effectLst/>
-                <a:latin typeface="+mn-lt"/>
-                <a:ea typeface="+mn-ea"/>
-                <a:cs typeface="+mn-cs"/>
-              </a:rPr>
-              <a:t> – </a:t>
-            </a:r>
-            <a:r>
-              <a:rPr lang="en-PH" sz="1200" b="0" i="0" kern="1200" dirty="0" err="1">
-                <a:solidFill>
-                  <a:schemeClr val="tx1"/>
-                </a:solidFill>
-                <a:effectLst/>
-                <a:latin typeface="+mn-lt"/>
-                <a:ea typeface="+mn-ea"/>
-                <a:cs typeface="+mn-cs"/>
-              </a:rPr>
-              <a:t>mean_attriters</a:t>
-            </a:r>
-            <a:r>
-              <a:rPr lang="en-PH" sz="1200" b="0" i="0" kern="1200" dirty="0">
-                <a:solidFill>
-                  <a:schemeClr val="tx1"/>
-                </a:solidFill>
-                <a:effectLst/>
-                <a:latin typeface="+mn-lt"/>
-                <a:ea typeface="+mn-ea"/>
-                <a:cs typeface="+mn-cs"/>
-              </a:rPr>
-              <a:t>) /  SE </a:t>
-            </a:r>
-          </a:p>
+        </p:txBody>
+      </p:sp>
+      <p:sp>
+        <p:nvSpPr>
+          <p:cNvPr id="4" name="Slide Number Placeholder 3"/>
+          <p:cNvSpPr>
+            <a:spLocks noGrp="1"/>
+          </p:cNvSpPr>
+          <p:nvPr>
+            <p:ph type="sldNum" sz="quarter" idx="5"/>
+          </p:nvPr>
+        </p:nvSpPr>
+        <p:spPr/>
+        <p:txBody>
+          <a:bodyPr/>
+          <a:lstStyle/>
+          <a:p>
+            <a:fld id="{BA95E93F-2514-4B81-921C-6961CBA23D3B}" type="slidenum">
+              <a:rPr lang="en-PH" smtClean="0"/>
+              <a:t>10</a:t>
+            </a:fld>
+            <a:endParaRPr lang="en-PH"/>
+          </a:p>
+        </p:txBody>
+      </p:sp>
+    </p:spTree>
+    <p:extLst>
+      <p:ext uri="{BB962C8B-B14F-4D97-AF65-F5344CB8AC3E}">
+        <p14:creationId xmlns:p14="http://schemas.microsoft.com/office/powerpoint/2010/main" val="2083346032"/>
+      </p:ext>
+    </p:extLst>
+  </p:cSld>
+  <p:clrMapOvr>
+    <a:masterClrMapping/>
+  </p:clrMapOvr>
+</p:notes>
+</file>
+
+<file path=ppt/notesSlides/notesSlide6.xml><?xml version="1.0" encoding="utf-8"?>
+<p:notes xmlns:a="http://schemas.openxmlformats.org/drawingml/2006/main" xmlns:r="http://schemas.openxmlformats.org/officeDocument/2006/relationships" xmlns:p="http://schemas.openxmlformats.org/presentationml/2006/main">
+  <p:cSld>
+    <p:spTree>
+      <p:nvGrpSpPr>
+        <p:cNvPr id="1" name=""/>
+        <p:cNvGrpSpPr/>
+        <p:nvPr/>
+      </p:nvGrpSpPr>
+      <p:grpSpPr>
+        <a:xfrm>
+          <a:off x="0" y="0"/>
+          <a:ext cx="0" cy="0"/>
+          <a:chOff x="0" y="0"/>
+          <a:chExt cx="0" cy="0"/>
+        </a:xfrm>
+      </p:grpSpPr>
+      <p:sp>
+        <p:nvSpPr>
+          <p:cNvPr id="2" name="Slide Image Placeholder 1"/>
+          <p:cNvSpPr>
+            <a:spLocks noGrp="1" noRot="1" noChangeAspect="1"/>
+          </p:cNvSpPr>
+          <p:nvPr>
+            <p:ph type="sldImg"/>
+          </p:nvPr>
+        </p:nvSpPr>
+        <p:spPr/>
+      </p:sp>
+      <p:sp>
+        <p:nvSpPr>
+          <p:cNvPr id="3" name="Notes Placeholder 2"/>
+          <p:cNvSpPr>
+            <a:spLocks noGrp="1"/>
+          </p:cNvSpPr>
+          <p:nvPr>
+            <p:ph type="body" idx="1"/>
+          </p:nvPr>
+        </p:nvSpPr>
+        <p:spPr/>
+        <p:txBody>
+          <a:bodyPr/>
+          <a:lstStyle/>
           <a:p>
             <a:pPr marL="171450" marR="0" lvl="0" indent="-171450" algn="l" defTabSz="914400" rtl="0" eaLnBrk="1" fontAlgn="auto" latinLnBrk="0" hangingPunct="1">
               <a:lnSpc>
@@ -3050,191 +1868,6 @@
               <a:cs typeface="+mn-cs"/>
             </a:endParaRPr>
           </a:p>
-          <a:p>
-            <a:pPr marL="0" marR="0" lvl="0" indent="0" algn="l" defTabSz="914400" rtl="0" eaLnBrk="1" fontAlgn="auto" latinLnBrk="0" hangingPunct="1">
-              <a:lnSpc>
-                <a:spcPct val="100000"/>
-              </a:lnSpc>
-              <a:spcBef>
-                <a:spcPts val="0"/>
-              </a:spcBef>
-              <a:spcAft>
-                <a:spcPts val="0"/>
-              </a:spcAft>
-              <a:buClrTx/>
-              <a:buSzTx/>
-              <a:buFont typeface="Arial" panose="020B0604020202020204" pitchFamily="34" charset="0"/>
-              <a:buNone/>
-              <a:tabLst/>
-              <a:defRPr/>
-            </a:pPr>
-            <a:r>
-              <a:rPr lang="en-PH" sz="1200" b="1" i="0" kern="1200" dirty="0">
-                <a:solidFill>
-                  <a:schemeClr val="tx1"/>
-                </a:solidFill>
-                <a:effectLst/>
-                <a:latin typeface="+mn-lt"/>
-                <a:ea typeface="+mn-ea"/>
-                <a:cs typeface="+mn-cs"/>
-              </a:rPr>
-              <a:t>Cohen’s d – </a:t>
-            </a:r>
-            <a:r>
-              <a:rPr lang="en-US" sz="1200" b="1" i="0" kern="1200" dirty="0">
-                <a:solidFill>
-                  <a:schemeClr val="tx1"/>
-                </a:solidFill>
-                <a:effectLst/>
-                <a:latin typeface="+mn-lt"/>
-                <a:ea typeface="+mn-ea"/>
-                <a:cs typeface="+mn-cs"/>
-              </a:rPr>
-              <a:t>If real, is it actually meaningful?</a:t>
-            </a:r>
-          </a:p>
-          <a:p>
-            <a:pPr marL="0" marR="0" lvl="0" indent="0" algn="l" defTabSz="914400" rtl="0" eaLnBrk="1" fontAlgn="auto" latinLnBrk="0" hangingPunct="1">
-              <a:lnSpc>
-                <a:spcPct val="100000"/>
-              </a:lnSpc>
-              <a:spcBef>
-                <a:spcPts val="0"/>
-              </a:spcBef>
-              <a:spcAft>
-                <a:spcPts val="0"/>
-              </a:spcAft>
-              <a:buClrTx/>
-              <a:buSzTx/>
-              <a:buFont typeface="Arial" panose="020B0604020202020204" pitchFamily="34" charset="0"/>
-              <a:buNone/>
-              <a:tabLst/>
-              <a:defRPr/>
-            </a:pPr>
-            <a:endParaRPr lang="en-US" sz="1200" b="0" i="0" kern="1200" dirty="0">
-              <a:solidFill>
-                <a:schemeClr val="tx1"/>
-              </a:solidFill>
-              <a:effectLst/>
-              <a:latin typeface="+mn-lt"/>
-              <a:ea typeface="+mn-ea"/>
-              <a:cs typeface="+mn-cs"/>
-            </a:endParaRPr>
-          </a:p>
-          <a:p>
-            <a:pPr marL="171450" marR="0" lvl="0" indent="-171450" algn="l" defTabSz="914400" rtl="0" eaLnBrk="1" fontAlgn="auto" latinLnBrk="0" hangingPunct="1">
-              <a:lnSpc>
-                <a:spcPct val="100000"/>
-              </a:lnSpc>
-              <a:spcBef>
-                <a:spcPts val="0"/>
-              </a:spcBef>
-              <a:spcAft>
-                <a:spcPts val="0"/>
-              </a:spcAft>
-              <a:buClrTx/>
-              <a:buSzTx/>
-              <a:buFont typeface="Arial" panose="020B0604020202020204" pitchFamily="34" charset="0"/>
-              <a:buChar char="•"/>
-              <a:tabLst/>
-              <a:defRPr/>
-            </a:pPr>
-            <a:r>
-              <a:rPr lang="en-PH" sz="1200" b="0" i="0" kern="1200" dirty="0">
-                <a:solidFill>
-                  <a:schemeClr val="tx1"/>
-                </a:solidFill>
-                <a:effectLst/>
-                <a:latin typeface="+mn-lt"/>
-                <a:ea typeface="+mn-ea"/>
-                <a:cs typeface="+mn-cs"/>
-              </a:rPr>
-              <a:t>compares how many STD the diff between mean of stayers and </a:t>
-            </a:r>
-            <a:r>
-              <a:rPr lang="en-PH" sz="1200" b="0" i="0" kern="1200" dirty="0" err="1">
-                <a:solidFill>
-                  <a:schemeClr val="tx1"/>
-                </a:solidFill>
-                <a:effectLst/>
-                <a:latin typeface="+mn-lt"/>
-                <a:ea typeface="+mn-ea"/>
-                <a:cs typeface="+mn-cs"/>
-              </a:rPr>
-              <a:t>attriters</a:t>
-            </a:r>
-            <a:r>
-              <a:rPr lang="en-PH" sz="1200" b="0" i="0" kern="1200" dirty="0">
-                <a:solidFill>
-                  <a:schemeClr val="tx1"/>
-                </a:solidFill>
-                <a:effectLst/>
-                <a:latin typeface="+mn-lt"/>
-                <a:ea typeface="+mn-ea"/>
-                <a:cs typeface="+mn-cs"/>
-              </a:rPr>
-              <a:t> </a:t>
-            </a:r>
-          </a:p>
-          <a:p>
-            <a:pPr marL="171450" marR="0" lvl="0" indent="-171450" algn="l" defTabSz="914400" rtl="0" eaLnBrk="1" fontAlgn="auto" latinLnBrk="0" hangingPunct="1">
-              <a:lnSpc>
-                <a:spcPct val="100000"/>
-              </a:lnSpc>
-              <a:spcBef>
-                <a:spcPts val="0"/>
-              </a:spcBef>
-              <a:spcAft>
-                <a:spcPts val="0"/>
-              </a:spcAft>
-              <a:buClrTx/>
-              <a:buSzTx/>
-              <a:buFont typeface="Arial" panose="020B0604020202020204" pitchFamily="34" charset="0"/>
-              <a:buChar char="•"/>
-              <a:tabLst/>
-              <a:defRPr/>
-            </a:pPr>
-            <a:r>
-              <a:rPr lang="en-PH" sz="1200" b="0" i="0" kern="1200" dirty="0">
-                <a:solidFill>
-                  <a:schemeClr val="tx1"/>
-                </a:solidFill>
-                <a:effectLst/>
-                <a:latin typeface="+mn-lt"/>
-                <a:ea typeface="+mn-ea"/>
-                <a:cs typeface="+mn-cs"/>
-              </a:rPr>
-              <a:t>&lt; 0.2: Negligible; 0.2 – 0.5: Small; 0.5 – 0.8: Medium;  &gt; 0.8Large</a:t>
-            </a:r>
-          </a:p>
-          <a:p>
-            <a:pPr marL="171450" marR="0" lvl="0" indent="-171450" algn="l" defTabSz="914400" rtl="0" eaLnBrk="1" fontAlgn="auto" latinLnBrk="0" hangingPunct="1">
-              <a:lnSpc>
-                <a:spcPct val="100000"/>
-              </a:lnSpc>
-              <a:spcBef>
-                <a:spcPts val="0"/>
-              </a:spcBef>
-              <a:spcAft>
-                <a:spcPts val="0"/>
-              </a:spcAft>
-              <a:buClrTx/>
-              <a:buSzTx/>
-              <a:buFont typeface="Arial" panose="020B0604020202020204" pitchFamily="34" charset="0"/>
-              <a:buChar char="•"/>
-              <a:tabLst/>
-              <a:defRPr/>
-            </a:pPr>
-            <a:endParaRPr lang="en-PH" sz="1200" b="0" i="0" kern="1200" dirty="0">
-              <a:solidFill>
-                <a:schemeClr val="tx1"/>
-              </a:solidFill>
-              <a:effectLst/>
-              <a:latin typeface="+mn-lt"/>
-              <a:ea typeface="+mn-ea"/>
-              <a:cs typeface="+mn-cs"/>
-            </a:endParaRPr>
-          </a:p>
         </p:txBody>
       </p:sp>
       <p:sp>
@@ -3264,119 +1897,6 @@
     <p:extLst>
       <p:ext uri="{BB962C8B-B14F-4D97-AF65-F5344CB8AC3E}">
         <p14:creationId xmlns:p14="http://schemas.microsoft.com/office/powerpoint/2010/main" val="1638273166"/>
-      </p:ext>
-    </p:extLst>
-  </p:cSld>
-  <p:clrMapOvr>
-    <a:masterClrMapping/>
-  </p:clrMapOvr>
-</p:notes>
-</file>
-
-<file path=ppt/notesSlides/notesSlide6.xml><?xml version="1.0" encoding="utf-8"?>
-<p:notes xmlns:a="http://schemas.openxmlformats.org/drawingml/2006/main" xmlns:r="http://schemas.openxmlformats.org/officeDocument/2006/relationships" xmlns:p="http://schemas.openxmlformats.org/presentationml/2006/main">
-  <p:cSld>
-    <p:spTree>
-      <p:nvGrpSpPr>
-        <p:cNvPr id="1" name=""/>
-        <p:cNvGrpSpPr/>
-        <p:nvPr/>
-      </p:nvGrpSpPr>
-      <p:grpSpPr>
-        <a:xfrm>
-          <a:off x="0" y="0"/>
-          <a:ext cx="0" cy="0"/>
-          <a:chOff x="0" y="0"/>
-          <a:chExt cx="0" cy="0"/>
-        </a:xfrm>
-      </p:grpSpPr>
-      <p:sp>
-        <p:nvSpPr>
-          <p:cNvPr id="2" name="Slide Image Placeholder 1"/>
-          <p:cNvSpPr>
-            <a:spLocks noGrp="1" noRot="1" noChangeAspect="1"/>
-          </p:cNvSpPr>
-          <p:nvPr>
-            <p:ph type="sldImg"/>
-          </p:nvPr>
-        </p:nvSpPr>
-        <p:spPr/>
-      </p:sp>
-      <p:sp>
-        <p:nvSpPr>
-          <p:cNvPr id="3" name="Notes Placeholder 2"/>
-          <p:cNvSpPr>
-            <a:spLocks noGrp="1"/>
-          </p:cNvSpPr>
-          <p:nvPr>
-            <p:ph type="body" idx="1"/>
-          </p:nvPr>
-        </p:nvSpPr>
-        <p:spPr/>
-        <p:txBody>
-          <a:bodyPr/>
-          <a:lstStyle/>
-          <a:p>
-            <a:r>
-              <a:rPr lang="en-PH" dirty="0"/>
-              <a:t>This might signal that nonlinear modeling might help. </a:t>
-            </a:r>
-          </a:p>
-          <a:p>
-            <a:endParaRPr lang="en-PH" dirty="0"/>
-          </a:p>
-          <a:p>
-            <a:r>
-              <a:rPr lang="en-PH" dirty="0"/>
-              <a:t>This is actually still bivariate analysis since linear correlation test with attrition flag</a:t>
-            </a:r>
-          </a:p>
-          <a:p>
-            <a:endParaRPr lang="en-PH" dirty="0"/>
-          </a:p>
-          <a:p>
-            <a:r>
-              <a:rPr lang="en-PH" dirty="0"/>
-              <a:t>Pearson r = </a:t>
-            </a:r>
-            <a:r>
-              <a:rPr lang="en-PH" dirty="0" err="1"/>
-              <a:t>covar</a:t>
-            </a:r>
-            <a:r>
-              <a:rPr lang="en-PH" dirty="0"/>
-              <a:t> / (STD X)(STD Y)</a:t>
-            </a:r>
-          </a:p>
-        </p:txBody>
-      </p:sp>
-      <p:sp>
-        <p:nvSpPr>
-          <p:cNvPr id="4" name="Slide Number Placeholder 3"/>
-          <p:cNvSpPr>
-            <a:spLocks noGrp="1"/>
-          </p:cNvSpPr>
-          <p:nvPr>
-            <p:ph type="sldNum" sz="quarter" idx="5"/>
-          </p:nvPr>
-        </p:nvSpPr>
-        <p:spPr/>
-        <p:txBody>
-          <a:bodyPr/>
-          <a:lstStyle/>
-          <a:p>
-            <a:fld id="{BA95E93F-2514-4B81-921C-6961CBA23D3B}" type="slidenum">
-              <a:rPr lang="en-PH" smtClean="0"/>
-              <a:t>12</a:t>
-            </a:fld>
-            <a:endParaRPr lang="en-PH"/>
-          </a:p>
-        </p:txBody>
-      </p:sp>
-    </p:spTree>
-    <p:extLst>
-      <p:ext uri="{BB962C8B-B14F-4D97-AF65-F5344CB8AC3E}">
-        <p14:creationId xmlns:p14="http://schemas.microsoft.com/office/powerpoint/2010/main" val="260132768"/>
       </p:ext>
     </p:extLst>
   </p:cSld>
@@ -3430,32 +1950,6 @@
           <a:bodyPr/>
           <a:lstStyle/>
           <a:p>
-            <a:r>
-              <a:rPr lang="en-PH" dirty="0"/>
-              <a:t>Near identical – from skewness test</a:t>
-            </a:r>
-          </a:p>
-          <a:p>
-            <a:endParaRPr lang="en-PH" dirty="0"/>
-          </a:p>
-          <a:p>
-            <a:r>
-              <a:rPr lang="en-PH" dirty="0"/>
-              <a:t>Categorical – from chi-square (association) and </a:t>
-            </a:r>
-            <a:r>
-              <a:rPr lang="en-PH" dirty="0" err="1"/>
-              <a:t>cramer’s</a:t>
-            </a:r>
-            <a:r>
-              <a:rPr lang="en-PH" dirty="0"/>
-              <a:t> (strength of association) test</a:t>
-            </a:r>
-          </a:p>
-          <a:p>
-            <a:endParaRPr lang="en-PH" dirty="0"/>
-          </a:p>
-          <a:p>
             <a:endParaRPr lang="en-PH" dirty="0"/>
           </a:p>
         </p:txBody>
@@ -3477,7 +1971,7 @@
           <a:p>
             <a:fld id="{BA95E93F-2514-4B81-921C-6961CBA23D3B}" type="slidenum">
               <a:rPr lang="en-PH" smtClean="0"/>
-              <a:t>13</a:t>
+              <a:t>12</a:t>
             </a:fld>
             <a:endParaRPr lang="en-PH"/>
           </a:p>
@@ -3486,7 +1980,7 @@
     </p:spTree>
     <p:extLst>
       <p:ext uri="{BB962C8B-B14F-4D97-AF65-F5344CB8AC3E}">
-        <p14:creationId xmlns:p14="http://schemas.microsoft.com/office/powerpoint/2010/main" val="3413641764"/>
+        <p14:creationId xmlns:p14="http://schemas.microsoft.com/office/powerpoint/2010/main" val="260132768"/>
       </p:ext>
     </p:extLst>
   </p:cSld>
@@ -3540,204 +2034,6 @@
           <a:bodyPr/>
           <a:lstStyle/>
           <a:p>
-            <a:r>
-              <a:rPr lang="en-US" sz="1200" b="0" i="0" kern="1200" dirty="0" err="1">
-                <a:solidFill>
-                  <a:schemeClr val="tx1"/>
-                </a:solidFill>
-                <a:effectLst/>
-                <a:latin typeface="+mn-lt"/>
-                <a:ea typeface="+mn-ea"/>
-                <a:cs typeface="+mn-cs"/>
-              </a:rPr>
-              <a:t>Insiginificant</a:t>
-            </a:r>
-            <a:r>
-              <a:rPr lang="en-US" sz="1200" b="0" i="0" kern="1200" dirty="0">
-                <a:solidFill>
-                  <a:schemeClr val="tx1"/>
-                </a:solidFill>
-                <a:effectLst/>
-                <a:latin typeface="+mn-lt"/>
-                <a:ea typeface="+mn-ea"/>
-                <a:cs typeface="+mn-cs"/>
-              </a:rPr>
-              <a:t> diff between churners and </a:t>
-            </a:r>
-            <a:r>
-              <a:rPr lang="en-US" sz="1200" b="0" i="0" kern="1200" dirty="0" err="1">
-                <a:solidFill>
-                  <a:schemeClr val="tx1"/>
-                </a:solidFill>
-                <a:effectLst/>
-                <a:latin typeface="+mn-lt"/>
-                <a:ea typeface="+mn-ea"/>
-                <a:cs typeface="+mn-cs"/>
-              </a:rPr>
-              <a:t>attriters</a:t>
-            </a:r>
-            <a:r>
-              <a:rPr lang="en-US" sz="1200" b="0" i="0" kern="1200" dirty="0">
-                <a:solidFill>
-                  <a:schemeClr val="tx1"/>
-                </a:solidFill>
-                <a:effectLst/>
-                <a:latin typeface="+mn-lt"/>
-                <a:ea typeface="+mn-ea"/>
-                <a:cs typeface="+mn-cs"/>
-              </a:rPr>
-              <a:t> using Welch’s t-test (association test) and Cohen’s d (strength of </a:t>
-            </a:r>
-            <a:r>
-              <a:rPr lang="en-US" sz="1200" b="0" i="0" kern="1200" dirty="0" err="1">
-                <a:solidFill>
-                  <a:schemeClr val="tx1"/>
-                </a:solidFill>
-                <a:effectLst/>
-                <a:latin typeface="+mn-lt"/>
-                <a:ea typeface="+mn-ea"/>
-                <a:cs typeface="+mn-cs"/>
-              </a:rPr>
-              <a:t>assoc</a:t>
-            </a:r>
-            <a:r>
-              <a:rPr lang="en-US" sz="1200" b="0" i="0" kern="1200" dirty="0">
-                <a:solidFill>
-                  <a:schemeClr val="tx1"/>
-                </a:solidFill>
-                <a:effectLst/>
-                <a:latin typeface="+mn-lt"/>
-                <a:ea typeface="+mn-ea"/>
-                <a:cs typeface="+mn-cs"/>
-              </a:rPr>
-              <a:t>)</a:t>
-            </a:r>
-          </a:p>
-          <a:p>
-            <a:endParaRPr lang="en-US" sz="1200" b="0" i="0" kern="1200" dirty="0">
-              <a:solidFill>
-                <a:schemeClr val="tx1"/>
-              </a:solidFill>
-              <a:effectLst/>
-              <a:latin typeface="+mn-lt"/>
-              <a:ea typeface="+mn-ea"/>
-              <a:cs typeface="+mn-cs"/>
-            </a:endParaRPr>
-          </a:p>
-          <a:p>
-            <a:r>
-              <a:rPr lang="en-US" sz="1200" b="0" i="0" kern="1200" dirty="0">
-                <a:solidFill>
-                  <a:schemeClr val="tx1"/>
-                </a:solidFill>
-                <a:effectLst/>
-                <a:latin typeface="+mn-lt"/>
-                <a:ea typeface="+mn-ea"/>
-                <a:cs typeface="+mn-cs"/>
-              </a:rPr>
-              <a:t>Percentage points = do </a:t>
-            </a:r>
-            <a:r>
-              <a:rPr lang="en-US" sz="1200" b="0" i="0" kern="1200" dirty="0" err="1">
-                <a:solidFill>
-                  <a:schemeClr val="tx1"/>
-                </a:solidFill>
-                <a:effectLst/>
-                <a:latin typeface="+mn-lt"/>
-                <a:ea typeface="+mn-ea"/>
-                <a:cs typeface="+mn-cs"/>
-              </a:rPr>
-              <a:t>is_negative</a:t>
-            </a:r>
-            <a:r>
-              <a:rPr lang="en-US" sz="1200" b="0" i="0" kern="1200" dirty="0">
-                <a:solidFill>
-                  <a:schemeClr val="tx1"/>
-                </a:solidFill>
-                <a:effectLst/>
-                <a:latin typeface="+mn-lt"/>
-                <a:ea typeface="+mn-ea"/>
-                <a:cs typeface="+mn-cs"/>
-              </a:rPr>
-              <a:t> flag = 1 produce higher churners versus global baseline rate </a:t>
-            </a:r>
-          </a:p>
-          <a:p>
-            <a:endParaRPr lang="en-US" sz="1200" b="0" i="0" kern="1200" dirty="0">
-              <a:solidFill>
-                <a:schemeClr val="tx1"/>
-              </a:solidFill>
-              <a:effectLst/>
-              <a:latin typeface="+mn-lt"/>
-              <a:ea typeface="+mn-ea"/>
-              <a:cs typeface="+mn-cs"/>
-            </a:endParaRPr>
-          </a:p>
-          <a:p>
-            <a:r>
-              <a:rPr lang="en-US" sz="1200" b="0" i="0" kern="1200" dirty="0">
-                <a:solidFill>
-                  <a:schemeClr val="tx1"/>
-                </a:solidFill>
-                <a:effectLst/>
-                <a:latin typeface="+mn-lt"/>
-                <a:ea typeface="+mn-ea"/>
-                <a:cs typeface="+mn-cs"/>
-              </a:rPr>
-              <a:t>Global churn rate (baseline) = 4.96%</a:t>
-            </a:r>
-          </a:p>
-          <a:p>
-            <a:r>
-              <a:rPr lang="en-US" sz="1200" b="0" i="0" kern="1200" dirty="0">
-                <a:solidFill>
-                  <a:schemeClr val="tx1"/>
-                </a:solidFill>
-                <a:effectLst/>
-                <a:latin typeface="+mn-lt"/>
-                <a:ea typeface="+mn-ea"/>
-                <a:cs typeface="+mn-cs"/>
-              </a:rPr>
-              <a:t>Churn rate when anomaly flag = 1 = 5.63%</a:t>
-            </a:r>
-          </a:p>
-          <a:p>
-            <a:endParaRPr lang="en-US" sz="1200" b="0" i="0" kern="1200" dirty="0">
-              <a:solidFill>
-                <a:schemeClr val="tx1"/>
-              </a:solidFill>
-              <a:effectLst/>
-              <a:latin typeface="+mn-lt"/>
-              <a:ea typeface="+mn-ea"/>
-              <a:cs typeface="+mn-cs"/>
-            </a:endParaRPr>
-          </a:p>
-          <a:p>
-            <a:r>
-              <a:rPr lang="en-US" sz="1200" b="0" i="0" kern="1200" dirty="0">
-                <a:solidFill>
-                  <a:schemeClr val="tx1"/>
-                </a:solidFill>
-                <a:effectLst/>
-                <a:latin typeface="+mn-lt"/>
-                <a:ea typeface="+mn-ea"/>
-                <a:cs typeface="+mn-cs"/>
-              </a:rPr>
-              <a:t>Lift = 5.63% - 4.96% = +0.67 pp</a:t>
-            </a:r>
-          </a:p>
-          <a:p>
-            <a:endParaRPr lang="en-US" sz="1200" b="0" i="0" kern="1200" dirty="0">
-              <a:solidFill>
-                <a:schemeClr val="tx1"/>
-              </a:solidFill>
-              <a:effectLst/>
-              <a:latin typeface="+mn-lt"/>
-              <a:ea typeface="+mn-ea"/>
-              <a:cs typeface="+mn-cs"/>
-            </a:endParaRPr>
-          </a:p>
-          <a:p>
             <a:endParaRPr lang="en-PH" dirty="0"/>
           </a:p>
         </p:txBody>
@@ -3759,7 +2055,7 @@
           <a:p>
             <a:fld id="{BA95E93F-2514-4B81-921C-6961CBA23D3B}" type="slidenum">
               <a:rPr lang="en-PH" smtClean="0"/>
-              <a:t>15</a:t>
+              <a:t>13</a:t>
             </a:fld>
             <a:endParaRPr lang="en-PH"/>
           </a:p>
@@ -3768,7 +2064,7 @@
     </p:spTree>
     <p:extLst>
       <p:ext uri="{BB962C8B-B14F-4D97-AF65-F5344CB8AC3E}">
-        <p14:creationId xmlns:p14="http://schemas.microsoft.com/office/powerpoint/2010/main" val="2837738001"/>
+        <p14:creationId xmlns:p14="http://schemas.microsoft.com/office/powerpoint/2010/main" val="3413641764"/>
       </p:ext>
     </p:extLst>
   </p:cSld>
@@ -3822,10 +2118,7 @@
           <a:bodyPr/>
           <a:lstStyle/>
           <a:p>
-            <a:r>
-              <a:rPr lang="en-PH" dirty="0"/>
-              <a:t>There’s no relationship bet length of tenure and churn</a:t>
-            </a:r>
+            <a:endParaRPr lang="en-PH" dirty="0"/>
           </a:p>
         </p:txBody>
       </p:sp>
@@ -3846,7 +2139,7 @@
           <a:p>
             <a:fld id="{BA95E93F-2514-4B81-921C-6961CBA23D3B}" type="slidenum">
               <a:rPr lang="en-PH" smtClean="0"/>
-              <a:t>16</a:t>
+              <a:t>15</a:t>
             </a:fld>
             <a:endParaRPr lang="en-PH"/>
           </a:p>
@@ -3855,7 +2148,7 @@
     </p:spTree>
     <p:extLst>
       <p:ext uri="{BB962C8B-B14F-4D97-AF65-F5344CB8AC3E}">
-        <p14:creationId xmlns:p14="http://schemas.microsoft.com/office/powerpoint/2010/main" val="3107776484"/>
+        <p14:creationId xmlns:p14="http://schemas.microsoft.com/office/powerpoint/2010/main" val="2837738001"/>
       </p:ext>
     </p:extLst>
   </p:cSld>
@@ -4014,7 +2307,7 @@
           <a:p>
             <a:fld id="{81E25AAC-E67F-4BC5-ADA8-09D7F4F5F138}" type="datetimeFigureOut">
               <a:rPr lang="en-PH" smtClean="0"/>
-              <a:t>15/03/2026</a:t>
+              <a:t>16/03/2026</a:t>
             </a:fld>
             <a:endParaRPr lang="en-PH"/>
           </a:p>
@@ -4214,7 +2507,7 @@
           <a:p>
             <a:fld id="{81E25AAC-E67F-4BC5-ADA8-09D7F4F5F138}" type="datetimeFigureOut">
               <a:rPr lang="en-PH" smtClean="0"/>
-              <a:t>15/03/2026</a:t>
+              <a:t>16/03/2026</a:t>
             </a:fld>
             <a:endParaRPr lang="en-PH"/>
           </a:p>
@@ -4424,7 +2717,7 @@
           <a:p>
             <a:fld id="{81E25AAC-E67F-4BC5-ADA8-09D7F4F5F138}" type="datetimeFigureOut">
               <a:rPr lang="en-PH" smtClean="0"/>
-              <a:t>15/03/2026</a:t>
+              <a:t>16/03/2026</a:t>
             </a:fld>
             <a:endParaRPr lang="en-PH"/>
           </a:p>
@@ -4624,7 +2917,7 @@
           <a:p>
             <a:fld id="{81E25AAC-E67F-4BC5-ADA8-09D7F4F5F138}" type="datetimeFigureOut">
               <a:rPr lang="en-PH" smtClean="0"/>
-              <a:t>15/03/2026</a:t>
+              <a:t>16/03/2026</a:t>
             </a:fld>
             <a:endParaRPr lang="en-PH"/>
           </a:p>
@@ -4900,7 +3193,7 @@
           <a:p>
             <a:fld id="{81E25AAC-E67F-4BC5-ADA8-09D7F4F5F138}" type="datetimeFigureOut">
               <a:rPr lang="en-PH" smtClean="0"/>
-              <a:t>15/03/2026</a:t>
+              <a:t>16/03/2026</a:t>
             </a:fld>
             <a:endParaRPr lang="en-PH"/>
           </a:p>
@@ -5168,7 +3461,7 @@
           <a:p>
             <a:fld id="{81E25AAC-E67F-4BC5-ADA8-09D7F4F5F138}" type="datetimeFigureOut">
               <a:rPr lang="en-PH" smtClean="0"/>
-              <a:t>15/03/2026</a:t>
+              <a:t>16/03/2026</a:t>
             </a:fld>
             <a:endParaRPr lang="en-PH"/>
           </a:p>
@@ -5583,7 +3876,7 @@
           <a:p>
             <a:fld id="{81E25AAC-E67F-4BC5-ADA8-09D7F4F5F138}" type="datetimeFigureOut">
               <a:rPr lang="en-PH" smtClean="0"/>
-              <a:t>15/03/2026</a:t>
+              <a:t>16/03/2026</a:t>
             </a:fld>
             <a:endParaRPr lang="en-PH"/>
           </a:p>
@@ -5725,7 +4018,7 @@
           <a:p>
             <a:fld id="{81E25AAC-E67F-4BC5-ADA8-09D7F4F5F138}" type="datetimeFigureOut">
               <a:rPr lang="en-PH" smtClean="0"/>
-              <a:t>15/03/2026</a:t>
+              <a:t>16/03/2026</a:t>
             </a:fld>
             <a:endParaRPr lang="en-PH"/>
           </a:p>
@@ -5838,7 +4131,7 @@
           <a:p>
             <a:fld id="{81E25AAC-E67F-4BC5-ADA8-09D7F4F5F138}" type="datetimeFigureOut">
               <a:rPr lang="en-PH" smtClean="0"/>
-              <a:t>15/03/2026</a:t>
+              <a:t>16/03/2026</a:t>
             </a:fld>
             <a:endParaRPr lang="en-PH"/>
           </a:p>
@@ -6151,7 +4444,7 @@
           <a:p>
             <a:fld id="{81E25AAC-E67F-4BC5-ADA8-09D7F4F5F138}" type="datetimeFigureOut">
               <a:rPr lang="en-PH" smtClean="0"/>
-              <a:t>15/03/2026</a:t>
+              <a:t>16/03/2026</a:t>
             </a:fld>
             <a:endParaRPr lang="en-PH"/>
           </a:p>
@@ -6440,7 +4733,7 @@
           <a:p>
             <a:fld id="{81E25AAC-E67F-4BC5-ADA8-09D7F4F5F138}" type="datetimeFigureOut">
               <a:rPr lang="en-PH" smtClean="0"/>
-              <a:t>15/03/2026</a:t>
+              <a:t>16/03/2026</a:t>
             </a:fld>
             <a:endParaRPr lang="en-PH"/>
           </a:p>
@@ -6683,7 +4976,7 @@
           <a:p>
             <a:fld id="{81E25AAC-E67F-4BC5-ADA8-09D7F4F5F138}" type="datetimeFigureOut">
               <a:rPr lang="en-PH" smtClean="0"/>
-              <a:t>15/03/2026</a:t>
+              <a:t>16/03/2026</a:t>
             </a:fld>
             <a:endParaRPr lang="en-PH"/>
           </a:p>
@@ -7434,334 +5727,6 @@
       </p:sp>
       <p:sp>
         <p:nvSpPr>
-          <p:cNvPr id="9" name="TextBox 8">
-            <a:extLst>
-              <a:ext uri="{FF2B5EF4-FFF2-40B4-BE49-F238E27FC236}">
-                <a16:creationId xmlns:a16="http://schemas.microsoft.com/office/drawing/2014/main" id="{85A75882-065B-6BA2-653F-7486670C9C9C}"/>
-              </a:ext>
-            </a:extLst>
-          </p:cNvPr>
-          <p:cNvSpPr txBox="1"/>
-          <p:nvPr/>
-        </p:nvSpPr>
-        <p:spPr>
-          <a:xfrm>
-            <a:off x="914400" y="3931920"/>
-            <a:ext cx="2286000" cy="646331"/>
-          </a:xfrm>
-          <a:prstGeom prst="rect">
-            <a:avLst/>
-          </a:prstGeom>
-          <a:noFill/>
-        </p:spPr>
-        <p:txBody>
-          <a:bodyPr vert="horz" wrap="square" lIns="0" tIns="0" rIns="0" bIns="0" rtlCol="0">
-            <a:noAutofit/>
-          </a:bodyPr>
-          <a:lstStyle/>
-          <a:p>
-            <a:pPr algn="ctr"/>
-            <a:r>
-              <a:rPr lang="en-PH" sz="3600" b="1">
-                <a:solidFill>
-                  <a:srgbClr val="F08248"/>
-                </a:solidFill>
-                <a:latin typeface="Arial" panose="020B0604020202020204" pitchFamily="34" charset="0"/>
-              </a:rPr>
-              <a:t>100K</a:t>
-            </a:r>
-          </a:p>
-        </p:txBody>
-      </p:sp>
-      <p:sp>
-        <p:nvSpPr>
-          <p:cNvPr id="10" name="TextBox 9">
-            <a:extLst>
-              <a:ext uri="{FF2B5EF4-FFF2-40B4-BE49-F238E27FC236}">
-                <a16:creationId xmlns:a16="http://schemas.microsoft.com/office/drawing/2014/main" id="{08932428-0242-EF97-BB95-69BC80119391}"/>
-              </a:ext>
-            </a:extLst>
-          </p:cNvPr>
-          <p:cNvSpPr txBox="1"/>
-          <p:nvPr/>
-        </p:nvSpPr>
-        <p:spPr>
-          <a:xfrm>
-            <a:off x="914400" y="4434840"/>
-            <a:ext cx="2286000" cy="276999"/>
-          </a:xfrm>
-          <a:prstGeom prst="rect">
-            <a:avLst/>
-          </a:prstGeom>
-          <a:noFill/>
-        </p:spPr>
-        <p:txBody>
-          <a:bodyPr vert="horz" wrap="square" lIns="0" tIns="0" rIns="0" bIns="0" rtlCol="0">
-            <a:noAutofit/>
-          </a:bodyPr>
-          <a:lstStyle/>
-          <a:p>
-            <a:pPr algn="ctr"/>
-            <a:r>
-              <a:rPr lang="en-PH" sz="1200">
-                <a:solidFill>
-                  <a:srgbClr val="9E9E9E"/>
-                </a:solidFill>
-                <a:latin typeface="Arial" panose="020B0604020202020204" pitchFamily="34" charset="0"/>
-              </a:rPr>
-              <a:t>Customer Records</a:t>
-            </a:r>
-          </a:p>
-        </p:txBody>
-      </p:sp>
-      <p:sp>
-        <p:nvSpPr>
-          <p:cNvPr id="11" name="TextBox 10">
-            <a:extLst>
-              <a:ext uri="{FF2B5EF4-FFF2-40B4-BE49-F238E27FC236}">
-                <a16:creationId xmlns:a16="http://schemas.microsoft.com/office/drawing/2014/main" id="{AF763818-2B81-54CE-8DC5-381E0A61C8B0}"/>
-              </a:ext>
-            </a:extLst>
-          </p:cNvPr>
-          <p:cNvSpPr txBox="1"/>
-          <p:nvPr/>
-        </p:nvSpPr>
-        <p:spPr>
-          <a:xfrm>
-            <a:off x="3474720" y="3931920"/>
-            <a:ext cx="2286000" cy="646331"/>
-          </a:xfrm>
-          <a:prstGeom prst="rect">
-            <a:avLst/>
-          </a:prstGeom>
-          <a:noFill/>
-        </p:spPr>
-        <p:txBody>
-          <a:bodyPr vert="horz" wrap="square" lIns="0" tIns="0" rIns="0" bIns="0" rtlCol="0">
-            <a:noAutofit/>
-          </a:bodyPr>
-          <a:lstStyle/>
-          <a:p>
-            <a:pPr algn="ctr"/>
-            <a:r>
-              <a:rPr lang="en-PH" sz="3600" b="1">
-                <a:solidFill>
-                  <a:srgbClr val="F08248"/>
-                </a:solidFill>
-                <a:latin typeface="Arial" panose="020B0604020202020204" pitchFamily="34" charset="0"/>
-              </a:rPr>
-              <a:t>13</a:t>
-            </a:r>
-          </a:p>
-        </p:txBody>
-      </p:sp>
-      <p:sp>
-        <p:nvSpPr>
-          <p:cNvPr id="12" name="TextBox 11">
-            <a:extLst>
-              <a:ext uri="{FF2B5EF4-FFF2-40B4-BE49-F238E27FC236}">
-                <a16:creationId xmlns:a16="http://schemas.microsoft.com/office/drawing/2014/main" id="{FD71FC2B-A975-C6E6-C954-703FA7C499E8}"/>
-              </a:ext>
-            </a:extLst>
-          </p:cNvPr>
-          <p:cNvSpPr txBox="1"/>
-          <p:nvPr/>
-        </p:nvSpPr>
-        <p:spPr>
-          <a:xfrm>
-            <a:off x="3474720" y="4434840"/>
-            <a:ext cx="2286000" cy="276999"/>
-          </a:xfrm>
-          <a:prstGeom prst="rect">
-            <a:avLst/>
-          </a:prstGeom>
-          <a:noFill/>
-        </p:spPr>
-        <p:txBody>
-          <a:bodyPr vert="horz" wrap="square" lIns="0" tIns="0" rIns="0" bIns="0" rtlCol="0">
-            <a:noAutofit/>
-          </a:bodyPr>
-          <a:lstStyle/>
-          <a:p>
-            <a:pPr algn="ctr"/>
-            <a:r>
-              <a:rPr lang="en-PH" sz="1200">
-                <a:solidFill>
-                  <a:srgbClr val="9E9E9E"/>
-                </a:solidFill>
-                <a:latin typeface="Arial" panose="020B0604020202020204" pitchFamily="34" charset="0"/>
-              </a:rPr>
-              <a:t>Core Features</a:t>
-            </a:r>
-          </a:p>
-        </p:txBody>
-      </p:sp>
-      <p:sp>
-        <p:nvSpPr>
-          <p:cNvPr id="13" name="TextBox 12">
-            <a:extLst>
-              <a:ext uri="{FF2B5EF4-FFF2-40B4-BE49-F238E27FC236}">
-                <a16:creationId xmlns:a16="http://schemas.microsoft.com/office/drawing/2014/main" id="{603F8A1C-6E21-50EA-60E6-1CE135FF1E8C}"/>
-              </a:ext>
-            </a:extLst>
-          </p:cNvPr>
-          <p:cNvSpPr txBox="1"/>
-          <p:nvPr/>
-        </p:nvSpPr>
-        <p:spPr>
-          <a:xfrm>
-            <a:off x="6035040" y="3931920"/>
-            <a:ext cx="2286000" cy="646331"/>
-          </a:xfrm>
-          <a:prstGeom prst="rect">
-            <a:avLst/>
-          </a:prstGeom>
-          <a:noFill/>
-        </p:spPr>
-        <p:txBody>
-          <a:bodyPr vert="horz" wrap="square" lIns="0" tIns="0" rIns="0" bIns="0" rtlCol="0">
-            <a:noAutofit/>
-          </a:bodyPr>
-          <a:lstStyle/>
-          <a:p>
-            <a:pPr algn="ctr"/>
-            <a:r>
-              <a:rPr lang="en-PH" sz="3600" b="1">
-                <a:solidFill>
-                  <a:srgbClr val="F08248"/>
-                </a:solidFill>
-                <a:latin typeface="Arial" panose="020B0604020202020204" pitchFamily="34" charset="0"/>
-              </a:rPr>
-              <a:t>~5%</a:t>
-            </a:r>
-          </a:p>
-        </p:txBody>
-      </p:sp>
-      <p:sp>
-        <p:nvSpPr>
-          <p:cNvPr id="14" name="TextBox 13">
-            <a:extLst>
-              <a:ext uri="{FF2B5EF4-FFF2-40B4-BE49-F238E27FC236}">
-                <a16:creationId xmlns:a16="http://schemas.microsoft.com/office/drawing/2014/main" id="{44322AE6-CF1B-DE83-3A69-567904B10160}"/>
-              </a:ext>
-            </a:extLst>
-          </p:cNvPr>
-          <p:cNvSpPr txBox="1"/>
-          <p:nvPr/>
-        </p:nvSpPr>
-        <p:spPr>
-          <a:xfrm>
-            <a:off x="6035040" y="4434840"/>
-            <a:ext cx="2286000" cy="276999"/>
-          </a:xfrm>
-          <a:prstGeom prst="rect">
-            <a:avLst/>
-          </a:prstGeom>
-          <a:noFill/>
-        </p:spPr>
-        <p:txBody>
-          <a:bodyPr vert="horz" wrap="square" lIns="0" tIns="0" rIns="0" bIns="0" rtlCol="0">
-            <a:noAutofit/>
-          </a:bodyPr>
-          <a:lstStyle/>
-          <a:p>
-            <a:pPr algn="ctr"/>
-            <a:r>
-              <a:rPr lang="en-PH" sz="1200">
-                <a:solidFill>
-                  <a:srgbClr val="9E9E9E"/>
-                </a:solidFill>
-                <a:latin typeface="Arial" panose="020B0604020202020204" pitchFamily="34" charset="0"/>
-              </a:rPr>
-              <a:t>Churn Rate</a:t>
-            </a:r>
-          </a:p>
-        </p:txBody>
-      </p:sp>
-      <p:sp>
-        <p:nvSpPr>
-          <p:cNvPr id="15" name="TextBox 14">
-            <a:extLst>
-              <a:ext uri="{FF2B5EF4-FFF2-40B4-BE49-F238E27FC236}">
-                <a16:creationId xmlns:a16="http://schemas.microsoft.com/office/drawing/2014/main" id="{C423E857-49A3-0812-A260-5C686D04BDBD}"/>
-              </a:ext>
-            </a:extLst>
-          </p:cNvPr>
-          <p:cNvSpPr txBox="1"/>
-          <p:nvPr/>
-        </p:nvSpPr>
-        <p:spPr>
-          <a:xfrm>
-            <a:off x="8595360" y="3931920"/>
-            <a:ext cx="2286000" cy="646331"/>
-          </a:xfrm>
-          <a:prstGeom prst="rect">
-            <a:avLst/>
-          </a:prstGeom>
-          <a:noFill/>
-        </p:spPr>
-        <p:txBody>
-          <a:bodyPr vert="horz" wrap="square" lIns="0" tIns="0" rIns="0" bIns="0" rtlCol="0">
-            <a:noAutofit/>
-          </a:bodyPr>
-          <a:lstStyle/>
-          <a:p>
-            <a:pPr algn="ctr"/>
-            <a:r>
-              <a:rPr lang="en-PH" sz="3600" b="1">
-                <a:solidFill>
-                  <a:srgbClr val="F08248"/>
-                </a:solidFill>
-                <a:latin typeface="Arial" panose="020B0604020202020204" pitchFamily="34" charset="0"/>
-              </a:rPr>
-              <a:t>0.05</a:t>
-            </a:r>
-          </a:p>
-        </p:txBody>
-      </p:sp>
-      <p:sp>
-        <p:nvSpPr>
-          <p:cNvPr id="16" name="TextBox 15">
-            <a:extLst>
-              <a:ext uri="{FF2B5EF4-FFF2-40B4-BE49-F238E27FC236}">
-                <a16:creationId xmlns:a16="http://schemas.microsoft.com/office/drawing/2014/main" id="{6167A5EB-0A2F-FA9E-4CA3-4EFF94F80937}"/>
-              </a:ext>
-            </a:extLst>
-          </p:cNvPr>
-          <p:cNvSpPr txBox="1"/>
-          <p:nvPr/>
-        </p:nvSpPr>
-        <p:spPr>
-          <a:xfrm>
-            <a:off x="8595360" y="4434840"/>
-            <a:ext cx="2286000" cy="276999"/>
-          </a:xfrm>
-          <a:prstGeom prst="rect">
-            <a:avLst/>
-          </a:prstGeom>
-          <a:noFill/>
-        </p:spPr>
-        <p:txBody>
-          <a:bodyPr vert="horz" wrap="square" lIns="0" tIns="0" rIns="0" bIns="0" rtlCol="0">
-            <a:noAutofit/>
-          </a:bodyPr>
-          <a:lstStyle/>
-          <a:p>
-            <a:pPr algn="ctr"/>
-            <a:r>
-              <a:rPr lang="en-PH" sz="1200">
-                <a:solidFill>
-                  <a:srgbClr val="9E9E9E"/>
-                </a:solidFill>
-                <a:latin typeface="Arial" panose="020B0604020202020204" pitchFamily="34" charset="0"/>
-              </a:rPr>
-              <a:t>Best PR-AUC</a:t>
-            </a:r>
-          </a:p>
-        </p:txBody>
-      </p:sp>
-      <p:sp>
-        <p:nvSpPr>
           <p:cNvPr id="17" name="TextBox 16">
             <a:extLst>
               <a:ext uri="{FF2B5EF4-FFF2-40B4-BE49-F238E27FC236}">
@@ -24971,6 +22936,17 @@
               <a:t> applied</a:t>
             </a:r>
           </a:p>
+          <a:p>
+            <a:r>
+              <a:rPr lang="en-PH" sz="1400" dirty="0">
+                <a:solidFill>
+                  <a:srgbClr val="4B4B4B"/>
+                </a:solidFill>
+                <a:latin typeface="Arial" panose="020B0604020202020204" pitchFamily="34" charset="0"/>
+              </a:rPr>
+              <a:t>SMOTE resampling</a:t>
+            </a:r>
+          </a:p>
         </p:txBody>
       </p:sp>
       <p:sp>
@@ -25275,7 +23251,7 @@
                 </a:solidFill>
                 <a:latin typeface="Arial" panose="020B0604020202020204" pitchFamily="34" charset="0"/>
               </a:rPr>
-              <a:t>ADASYN: 80K -&gt; 151,704 rows (50/50)</a:t>
+              <a:t>SMOTE: 80K -&gt; 151,704 rows (50/50)</a:t>
             </a:r>
             <a:endParaRPr lang="en-PH" sz="1400" dirty="0">
               <a:solidFill>
@@ -27061,13 +25037,13 @@
           <a:p>
             <a:pPr algn="ctr"/>
             <a:r>
-              <a:rPr lang="en-PH" sz="1200">
+              <a:rPr lang="en-PH" sz="1200" dirty="0">
                 <a:solidFill>
                   <a:srgbClr val="9E9E9E"/>
                 </a:solidFill>
                 <a:latin typeface="Arial" panose="020B0604020202020204" pitchFamily="34" charset="0"/>
               </a:rPr>
-              <a:t>Post-ADASYN train (tree)</a:t>
+              <a:t>Post-SMOTE train</a:t>
             </a:r>
           </a:p>
         </p:txBody>
@@ -28422,28 +26398,46 @@
           <a:lstStyle/>
           <a:p>
             <a:r>
-              <a:rPr lang="en-US" sz="1300">
+              <a:rPr lang="en-US" sz="1300" dirty="0" err="1">
                 <a:solidFill>
                   <a:srgbClr val="4B4B4B"/>
                 </a:solidFill>
                 <a:latin typeface="Arial" panose="020B0604020202020204" pitchFamily="34" charset="0"/>
               </a:rPr>
-              <a:t>RandomizedSearchCV (60 iter)</a:t>
-            </a:r>
-          </a:p>
-          <a:p>
-            <a:r>
-              <a:rPr lang="en-US" sz="1300">
+              <a:t>RandomizedSearchCV</a:t>
+            </a:r>
+            <a:r>
+              <a:rPr lang="en-US" sz="1300" dirty="0">
                 <a:solidFill>
                   <a:srgbClr val="4B4B4B"/>
                 </a:solidFill>
                 <a:latin typeface="Arial" panose="020B0604020202020204" pitchFamily="34" charset="0"/>
               </a:rPr>
-              <a:t>scale_pos_weight = 19.16</a:t>
-            </a:r>
-          </a:p>
-          <a:p>
-            <a:endParaRPr lang="en-US" sz="1300">
+              <a:t> (60 iter)</a:t>
+            </a:r>
+          </a:p>
+          <a:p>
+            <a:r>
+              <a:rPr lang="en-US" sz="1300" dirty="0" err="1">
+                <a:solidFill>
+                  <a:srgbClr val="4B4B4B"/>
+                </a:solidFill>
+                <a:latin typeface="Arial" panose="020B0604020202020204" pitchFamily="34" charset="0"/>
+              </a:rPr>
+              <a:t>scale_pos_weight</a:t>
+            </a:r>
+            <a:r>
+              <a:rPr lang="en-US" sz="1300" dirty="0">
+                <a:solidFill>
+                  <a:srgbClr val="4B4B4B"/>
+                </a:solidFill>
+                <a:latin typeface="Arial" panose="020B0604020202020204" pitchFamily="34" charset="0"/>
+              </a:rPr>
+              <a:t> = 19.16</a:t>
+            </a:r>
+          </a:p>
+          <a:p>
+            <a:endParaRPr lang="en-US" sz="1300" dirty="0">
               <a:solidFill>
                 <a:srgbClr val="4B4B4B"/>
               </a:solidFill>
@@ -28452,28 +26446,28 @@
           </a:p>
           <a:p>
             <a:r>
-              <a:rPr lang="en-US" sz="1300">
+              <a:rPr lang="en-US" sz="1300" dirty="0">
                 <a:solidFill>
                   <a:srgbClr val="4B4B4B"/>
                 </a:solidFill>
                 <a:latin typeface="Arial" panose="020B0604020202020204" pitchFamily="34" charset="0"/>
               </a:rPr>
-              <a:t>All 6 engineered features</a:t>
-            </a:r>
-          </a:p>
-          <a:p>
-            <a:r>
-              <a:rPr lang="en-US" sz="1300">
+              <a:t>5/6 engineered features</a:t>
+            </a:r>
+          </a:p>
+          <a:p>
+            <a:r>
+              <a:rPr lang="en-US" sz="1300" dirty="0">
                 <a:solidFill>
                   <a:srgbClr val="4B4B4B"/>
                 </a:solidFill>
                 <a:latin typeface="Arial" panose="020B0604020202020204" pitchFamily="34" charset="0"/>
               </a:rPr>
-              <a:t>ADASYN-balanced training</a:t>
-            </a:r>
-          </a:p>
-          <a:p>
-            <a:endParaRPr lang="en-US" sz="1300">
+              <a:t>SMOTE-balanced training</a:t>
+            </a:r>
+          </a:p>
+          <a:p>
+            <a:endParaRPr lang="en-US" sz="1300" dirty="0">
               <a:solidFill>
                 <a:srgbClr val="4B4B4B"/>
               </a:solidFill>
@@ -28482,26 +26476,53 @@
           </a:p>
           <a:p>
             <a:r>
-              <a:rPr lang="en-US" sz="1300">
+              <a:rPr lang="en-US" sz="1300" dirty="0" err="1">
                 <a:solidFill>
                   <a:srgbClr val="4B4B4B"/>
                 </a:solidFill>
                 <a:latin typeface="Arial" panose="020B0604020202020204" pitchFamily="34" charset="0"/>
               </a:rPr>
-              <a:t>max_depth=3, lr=0.01</a:t>
-            </a:r>
-          </a:p>
-          <a:p>
-            <a:r>
-              <a:rPr lang="en-US" sz="1300">
+              <a:t>max_depth</a:t>
+            </a:r>
+            <a:r>
+              <a:rPr lang="en-US" sz="1300" dirty="0">
                 <a:solidFill>
                   <a:srgbClr val="4B4B4B"/>
                 </a:solidFill>
                 <a:latin typeface="Arial" panose="020B0604020202020204" pitchFamily="34" charset="0"/>
               </a:rPr>
+              <a:t>=3, </a:t>
+            </a:r>
+            <a:r>
+              <a:rPr lang="en-US" sz="1300" dirty="0" err="1">
+                <a:solidFill>
+                  <a:srgbClr val="4B4B4B"/>
+                </a:solidFill>
+                <a:latin typeface="Arial" panose="020B0604020202020204" pitchFamily="34" charset="0"/>
+              </a:rPr>
+              <a:t>lr</a:t>
+            </a:r>
+            <a:r>
+              <a:rPr lang="en-US" sz="1300" dirty="0">
+                <a:solidFill>
+                  <a:srgbClr val="4B4B4B"/>
+                </a:solidFill>
+                <a:latin typeface="Arial" panose="020B0604020202020204" pitchFamily="34" charset="0"/>
+              </a:rPr>
+              <a:t>=0.01</a:t>
+            </a:r>
+          </a:p>
+          <a:p>
+            <a:r>
+              <a:rPr lang="en-US" sz="1300" dirty="0">
+                <a:solidFill>
+                  <a:srgbClr val="4B4B4B"/>
+                </a:solidFill>
+                <a:latin typeface="Arial" panose="020B0604020202020204" pitchFamily="34" charset="0"/>
+              </a:rPr>
               <a:t>Best CV Recall: 0.1932</a:t>
             </a:r>
-            <a:endParaRPr lang="en-PH" sz="1300">
+            <a:endParaRPr lang="en-PH" sz="1300" dirty="0">
               <a:solidFill>
                 <a:srgbClr val="4B4B4B"/>
               </a:solidFill>
@@ -28610,15 +26631,15 @@
           <a:p>
             <a:pPr algn="ctr"/>
             <a:r>
-              <a:rPr lang="en-US" sz="1300">
+              <a:rPr lang="en-US" sz="2000" b="1" dirty="0">
                 <a:solidFill>
                   <a:srgbClr val="C8DCFC"/>
                 </a:solidFill>
                 <a:latin typeface="Arial" panose="020B0604020202020204" pitchFamily="34" charset="0"/>
               </a:rPr>
-              <a:t>Primary: PR-AUC (imbalance-aware)  |  Secondary: F2-Score (Recall-weighted)  |  Business: missed churner &gt; false alarm</a:t>
-            </a:r>
-            <a:endParaRPr lang="en-PH" sz="1300">
+              <a:t>Selection Metric: Recall</a:t>
+            </a:r>
+            <a:endParaRPr lang="en-PH" sz="2000" b="1" dirty="0">
               <a:solidFill>
                 <a:srgbClr val="C8DCFC"/>
               </a:solidFill>

</xml_diff>